<commit_message>
Diagramas de clases: usar el PNG real de PlantUML en vez del dibujo nativo
Reemplaza el diagrama dibujado a mano en PowerPoint por la imagen renderizada
de cada clases.puml (Decorator, Facade, Flyweight, Proxy), en mayor resolucion
(dpi 200). Se conservan titulo, stepper, panel de participantes y leyenda.
</commit_message>
<xml_diff>
--- a/entrega/Presentacion_Patrones_Grupo3_FINAL.pptx
+++ b/entrega/Presentacion_Patrones_Grupo3_FINAL.pptx
@@ -9448,1035 +9448,6 @@
       </p:sp>
       <p:sp>
         <p:nvSpPr>
-          <p:cNvPr id="23" name="Shape 21"/>
-          <p:cNvSpPr/>
-          <p:nvPr/>
-        </p:nvSpPr>
-        <p:spPr>
-          <a:xfrm>
-            <a:off x="457200" y="2103120"/>
-            <a:ext cx="1554480" cy="722376"/>
-          </a:xfrm>
-          <a:prstGeom prst="rect">
-            <a:avLst/>
-          </a:prstGeom>
-          <a:solidFill>
-            <a:srgbClr val="FFFFFF"/>
-          </a:solidFill>
-          <a:ln w="15875">
-            <a:solidFill>
-              <a:srgbClr val="3A3F4B"/>
-            </a:solidFill>
-            <a:prstDash val="solid"/>
-          </a:ln>
-        </p:spPr>
-      </p:sp>
-      <p:sp>
-        <p:nvSpPr>
-          <p:cNvPr id="24" name="Shape 22"/>
-          <p:cNvSpPr/>
-          <p:nvPr/>
-        </p:nvSpPr>
-        <p:spPr>
-          <a:xfrm>
-            <a:off x="457200" y="2103120"/>
-            <a:ext cx="1554480" cy="457200"/>
-          </a:xfrm>
-          <a:prstGeom prst="rect">
-            <a:avLst/>
-          </a:prstGeom>
-          <a:solidFill>
-            <a:srgbClr val="5BB4F0"/>
-          </a:solidFill>
-          <a:ln w="15875">
-            <a:solidFill>
-              <a:srgbClr val="3A3F4B"/>
-            </a:solidFill>
-            <a:prstDash val="solid"/>
-          </a:ln>
-        </p:spPr>
-      </p:sp>
-      <p:sp>
-        <p:nvSpPr>
-          <p:cNvPr id="25" name="Text 23"/>
-          <p:cNvSpPr txBox="1"/>
-          <p:nvPr/>
-        </p:nvSpPr>
-        <p:spPr>
-          <a:xfrm>
-            <a:off x="457200" y="2103120"/>
-            <a:ext cx="1554480" cy="457200"/>
-          </a:xfrm>
-          <a:prstGeom prst="rect">
-            <a:avLst/>
-          </a:prstGeom>
-          <a:noFill/>
-          <a:ln/>
-        </p:spPr>
-        <p:txBody>
-          <a:bodyPr wrap="square" lIns="0" tIns="0" rIns="0" bIns="0" rtlCol="0" anchor="ctr"/>
-          <a:lstStyle/>
-          <a:p>
-            <a:pPr algn="ctr" indent="0" marL="0">
-              <a:buNone/>
-            </a:pPr>
-            <a:r>
-              <a:rPr lang="en-US" sz="800" i="1" dirty="0">
-                <a:solidFill>
-                  <a:srgbClr val="3A3F4B"/>
-                </a:solidFill>
-                <a:latin typeface="Calibri" pitchFamily="34" charset="0"/>
-                <a:ea typeface="Calibri" pitchFamily="34" charset="-122"/>
-                <a:cs typeface="Calibri" pitchFamily="34" charset="-120"/>
-              </a:rPr>
-              <a:t>«control»</a:t>
-            </a:r>
-            <a:endParaRPr lang="en-US" sz="1400" dirty="0"/>
-          </a:p>
-          <a:p>
-            <a:pPr algn="ctr" indent="0" marL="0">
-              <a:buNone/>
-            </a:pPr>
-            <a:r>
-              <a:rPr lang="en-US" sz="1100" b="1" dirty="0">
-                <a:solidFill>
-                  <a:srgbClr val="3A3F4B"/>
-                </a:solidFill>
-                <a:latin typeface="Calibri" pitchFamily="34" charset="0"/>
-                <a:ea typeface="Calibri" pitchFamily="34" charset="-122"/>
-                <a:cs typeface="Calibri" pitchFamily="34" charset="-120"/>
-              </a:rPr>
-              <a:t>Main</a:t>
-            </a:r>
-            <a:endParaRPr lang="en-US" sz="1400" dirty="0"/>
-          </a:p>
-        </p:txBody>
-      </p:sp>
-      <p:sp>
-        <p:nvSpPr>
-          <p:cNvPr id="26" name="Text 24"/>
-          <p:cNvSpPr txBox="1"/>
-          <p:nvPr/>
-        </p:nvSpPr>
-        <p:spPr>
-          <a:xfrm>
-            <a:off x="530352" y="2606040"/>
-            <a:ext cx="1444752" cy="219456"/>
-          </a:xfrm>
-          <a:prstGeom prst="rect">
-            <a:avLst/>
-          </a:prstGeom>
-          <a:noFill/>
-          <a:ln/>
-        </p:spPr>
-        <p:txBody>
-          <a:bodyPr wrap="square" lIns="0" tIns="0" rIns="0" bIns="0" rtlCol="0" anchor="t"/>
-          <a:lstStyle/>
-          <a:p>
-            <a:pPr indent="0" marL="0">
-              <a:buNone/>
-            </a:pPr>
-            <a:r>
-              <a:rPr lang="en-US" sz="850" dirty="0">
-                <a:solidFill>
-                  <a:srgbClr val="1B2333"/>
-                </a:solidFill>
-                <a:latin typeface="Courier New" pitchFamily="34" charset="0"/>
-                <a:ea typeface="Courier New" pitchFamily="34" charset="-122"/>
-                <a:cs typeface="Courier New" pitchFamily="34" charset="-120"/>
-              </a:rPr>
-              <a:t>(cliente)</a:t>
-            </a:r>
-            <a:endParaRPr lang="en-US" sz="850" dirty="0"/>
-          </a:p>
-        </p:txBody>
-      </p:sp>
-      <p:sp>
-        <p:nvSpPr>
-          <p:cNvPr id="27" name="Shape 25"/>
-          <p:cNvSpPr/>
-          <p:nvPr/>
-        </p:nvSpPr>
-        <p:spPr>
-          <a:xfrm>
-            <a:off x="2560320" y="1600200"/>
-            <a:ext cx="2514600" cy="1417320"/>
-          </a:xfrm>
-          <a:prstGeom prst="rect">
-            <a:avLst/>
-          </a:prstGeom>
-          <a:solidFill>
-            <a:srgbClr val="FFFFFF"/>
-          </a:solidFill>
-          <a:ln w="15875">
-            <a:solidFill>
-              <a:srgbClr val="3A3F4B"/>
-            </a:solidFill>
-            <a:prstDash val="solid"/>
-          </a:ln>
-        </p:spPr>
-      </p:sp>
-      <p:sp>
-        <p:nvSpPr>
-          <p:cNvPr id="28" name="Shape 26"/>
-          <p:cNvSpPr/>
-          <p:nvPr/>
-        </p:nvSpPr>
-        <p:spPr>
-          <a:xfrm>
-            <a:off x="2560320" y="1600200"/>
-            <a:ext cx="2514600" cy="457200"/>
-          </a:xfrm>
-          <a:prstGeom prst="rect">
-            <a:avLst/>
-          </a:prstGeom>
-          <a:solidFill>
-            <a:srgbClr val="3A3F4B"/>
-          </a:solidFill>
-          <a:ln w="15875">
-            <a:solidFill>
-              <a:srgbClr val="3A3F4B"/>
-            </a:solidFill>
-            <a:prstDash val="solid"/>
-          </a:ln>
-        </p:spPr>
-      </p:sp>
-      <p:sp>
-        <p:nvSpPr>
-          <p:cNvPr id="29" name="Text 27"/>
-          <p:cNvSpPr txBox="1"/>
-          <p:nvPr/>
-        </p:nvSpPr>
-        <p:spPr>
-          <a:xfrm>
-            <a:off x="2560320" y="1600200"/>
-            <a:ext cx="2514600" cy="457200"/>
-          </a:xfrm>
-          <a:prstGeom prst="rect">
-            <a:avLst/>
-          </a:prstGeom>
-          <a:noFill/>
-          <a:ln/>
-        </p:spPr>
-        <p:txBody>
-          <a:bodyPr wrap="square" lIns="0" tIns="0" rIns="0" bIns="0" rtlCol="0" anchor="ctr"/>
-          <a:lstStyle/>
-          <a:p>
-            <a:pPr algn="ctr" indent="0" marL="0">
-              <a:buNone/>
-            </a:pPr>
-            <a:r>
-              <a:rPr lang="en-US" sz="800" i="1" dirty="0">
-                <a:solidFill>
-                  <a:srgbClr val="CADCFC"/>
-                </a:solidFill>
-                <a:latin typeface="Calibri" pitchFamily="34" charset="0"/>
-                <a:ea typeface="Calibri" pitchFamily="34" charset="-122"/>
-                <a:cs typeface="Calibri" pitchFamily="34" charset="-120"/>
-              </a:rPr>
-              <a:t>«facade»</a:t>
-            </a:r>
-            <a:endParaRPr lang="en-US" sz="1400" dirty="0"/>
-          </a:p>
-          <a:p>
-            <a:pPr algn="ctr" indent="0" marL="0">
-              <a:buNone/>
-            </a:pPr>
-            <a:r>
-              <a:rPr lang="en-US" sz="1100" b="1" dirty="0">
-                <a:solidFill>
-                  <a:srgbClr val="FFFFFF"/>
-                </a:solidFill>
-                <a:latin typeface="Calibri" pitchFamily="34" charset="0"/>
-                <a:ea typeface="Calibri" pitchFamily="34" charset="-122"/>
-                <a:cs typeface="Calibri" pitchFamily="34" charset="-120"/>
-              </a:rPr>
-              <a:t>VentaTiquetesFacade</a:t>
-            </a:r>
-            <a:endParaRPr lang="en-US" sz="1400" dirty="0"/>
-          </a:p>
-        </p:txBody>
-      </p:sp>
-      <p:sp>
-        <p:nvSpPr>
-          <p:cNvPr id="30" name="Text 28"/>
-          <p:cNvSpPr txBox="1"/>
-          <p:nvPr/>
-        </p:nvSpPr>
-        <p:spPr>
-          <a:xfrm>
-            <a:off x="2633472" y="2103120"/>
-            <a:ext cx="2404872" cy="914400"/>
-          </a:xfrm>
-          <a:prstGeom prst="rect">
-            <a:avLst/>
-          </a:prstGeom>
-          <a:noFill/>
-          <a:ln/>
-        </p:spPr>
-        <p:txBody>
-          <a:bodyPr wrap="square" lIns="0" tIns="0" rIns="0" bIns="0" rtlCol="0" anchor="t"/>
-          <a:lstStyle/>
-          <a:p>
-            <a:pPr indent="0" marL="0">
-              <a:buNone/>
-            </a:pPr>
-            <a:r>
-              <a:rPr lang="en-US" sz="850" dirty="0">
-                <a:solidFill>
-                  <a:srgbClr val="1B2333"/>
-                </a:solidFill>
-                <a:latin typeface="Courier New" pitchFamily="34" charset="0"/>
-                <a:ea typeface="Courier New" pitchFamily="34" charset="-122"/>
-                <a:cs typeface="Courier New" pitchFamily="34" charset="-120"/>
-              </a:rPr>
-              <a:t>- inventario</a:t>
-            </a:r>
-            <a:endParaRPr lang="en-US" sz="850" dirty="0"/>
-          </a:p>
-          <a:p>
-            <a:pPr indent="0" marL="0">
-              <a:buNone/>
-            </a:pPr>
-            <a:r>
-              <a:rPr lang="en-US" sz="850" dirty="0">
-                <a:solidFill>
-                  <a:srgbClr val="1B2333"/>
-                </a:solidFill>
-                <a:latin typeface="Courier New" pitchFamily="34" charset="0"/>
-                <a:ea typeface="Courier New" pitchFamily="34" charset="-122"/>
-                <a:cs typeface="Courier New" pitchFamily="34" charset="-120"/>
-              </a:rPr>
-              <a:t>- pago</a:t>
-            </a:r>
-            <a:endParaRPr lang="en-US" sz="850" dirty="0"/>
-          </a:p>
-          <a:p>
-            <a:pPr indent="0" marL="0">
-              <a:buNone/>
-            </a:pPr>
-            <a:r>
-              <a:rPr lang="en-US" sz="850" dirty="0">
-                <a:solidFill>
-                  <a:srgbClr val="1B2333"/>
-                </a:solidFill>
-                <a:latin typeface="Courier New" pitchFamily="34" charset="0"/>
-                <a:ea typeface="Courier New" pitchFamily="34" charset="-122"/>
-                <a:cs typeface="Courier New" pitchFamily="34" charset="-120"/>
-              </a:rPr>
-              <a:t>- facturacion</a:t>
-            </a:r>
-            <a:endParaRPr lang="en-US" sz="850" dirty="0"/>
-          </a:p>
-          <a:p>
-            <a:pPr indent="0" marL="0">
-              <a:buNone/>
-            </a:pPr>
-            <a:r>
-              <a:rPr lang="en-US" sz="850" dirty="0">
-                <a:solidFill>
-                  <a:srgbClr val="1B2333"/>
-                </a:solidFill>
-                <a:latin typeface="Courier New" pitchFamily="34" charset="0"/>
-                <a:ea typeface="Courier New" pitchFamily="34" charset="-122"/>
-                <a:cs typeface="Courier New" pitchFamily="34" charset="-120"/>
-              </a:rPr>
-              <a:t>- notificaciones</a:t>
-            </a:r>
-            <a:endParaRPr lang="en-US" sz="850" dirty="0"/>
-          </a:p>
-          <a:p>
-            <a:pPr indent="0" marL="0">
-              <a:buNone/>
-            </a:pPr>
-            <a:r>
-              <a:rPr lang="en-US" sz="850" dirty="0">
-                <a:solidFill>
-                  <a:srgbClr val="1B2333"/>
-                </a:solidFill>
-                <a:latin typeface="Courier New" pitchFamily="34" charset="0"/>
-                <a:ea typeface="Courier New" pitchFamily="34" charset="-122"/>
-                <a:cs typeface="Courier New" pitchFamily="34" charset="-120"/>
-              </a:rPr>
-              <a:t>+ comprarTiquete(...)</a:t>
-            </a:r>
-            <a:endParaRPr lang="en-US" sz="850" dirty="0"/>
-          </a:p>
-        </p:txBody>
-      </p:sp>
-      <p:sp>
-        <p:nvSpPr>
-          <p:cNvPr id="31" name="Shape 29"/>
-          <p:cNvSpPr/>
-          <p:nvPr/>
-        </p:nvSpPr>
-        <p:spPr>
-          <a:xfrm>
-            <a:off x="5806440" y="960120"/>
-            <a:ext cx="2880360" cy="557784"/>
-          </a:xfrm>
-          <a:prstGeom prst="rect">
-            <a:avLst/>
-          </a:prstGeom>
-          <a:solidFill>
-            <a:srgbClr val="FFFFFF"/>
-          </a:solidFill>
-          <a:ln w="15875">
-            <a:solidFill>
-              <a:srgbClr val="3A3F4B"/>
-            </a:solidFill>
-            <a:prstDash val="solid"/>
-          </a:ln>
-        </p:spPr>
-      </p:sp>
-      <p:sp>
-        <p:nvSpPr>
-          <p:cNvPr id="32" name="Shape 30"/>
-          <p:cNvSpPr/>
-          <p:nvPr/>
-        </p:nvSpPr>
-        <p:spPr>
-          <a:xfrm>
-            <a:off x="5806440" y="960120"/>
-            <a:ext cx="2880360" cy="292608"/>
-          </a:xfrm>
-          <a:prstGeom prst="rect">
-            <a:avLst/>
-          </a:prstGeom>
-          <a:solidFill>
-            <a:srgbClr val="3A3F4B"/>
-          </a:solidFill>
-          <a:ln w="15875">
-            <a:solidFill>
-              <a:srgbClr val="3A3F4B"/>
-            </a:solidFill>
-            <a:prstDash val="solid"/>
-          </a:ln>
-        </p:spPr>
-      </p:sp>
-      <p:sp>
-        <p:nvSpPr>
-          <p:cNvPr id="33" name="Text 31"/>
-          <p:cNvSpPr txBox="1"/>
-          <p:nvPr/>
-        </p:nvSpPr>
-        <p:spPr>
-          <a:xfrm>
-            <a:off x="5806440" y="960120"/>
-            <a:ext cx="2880360" cy="292608"/>
-          </a:xfrm>
-          <a:prstGeom prst="rect">
-            <a:avLst/>
-          </a:prstGeom>
-          <a:noFill/>
-          <a:ln/>
-        </p:spPr>
-        <p:txBody>
-          <a:bodyPr wrap="square" lIns="0" tIns="0" rIns="0" bIns="0" rtlCol="0" anchor="ctr"/>
-          <a:lstStyle/>
-          <a:p>
-            <a:pPr algn="ctr" indent="0" marL="0">
-              <a:buNone/>
-            </a:pPr>
-            <a:r>
-              <a:rPr lang="en-US" sz="1100" b="1" dirty="0">
-                <a:solidFill>
-                  <a:srgbClr val="FFFFFF"/>
-                </a:solidFill>
-                <a:latin typeface="Calibri" pitchFamily="34" charset="0"/>
-                <a:ea typeface="Calibri" pitchFamily="34" charset="-122"/>
-                <a:cs typeface="Calibri" pitchFamily="34" charset="-120"/>
-              </a:rPr>
-              <a:t>InventarioSillas</a:t>
-            </a:r>
-            <a:endParaRPr lang="en-US" sz="1400" dirty="0"/>
-          </a:p>
-        </p:txBody>
-      </p:sp>
-      <p:sp>
-        <p:nvSpPr>
-          <p:cNvPr id="34" name="Text 32"/>
-          <p:cNvSpPr txBox="1"/>
-          <p:nvPr/>
-        </p:nvSpPr>
-        <p:spPr>
-          <a:xfrm>
-            <a:off x="5879592" y="1298448"/>
-            <a:ext cx="2770632" cy="219456"/>
-          </a:xfrm>
-          <a:prstGeom prst="rect">
-            <a:avLst/>
-          </a:prstGeom>
-          <a:noFill/>
-          <a:ln/>
-        </p:spPr>
-        <p:txBody>
-          <a:bodyPr wrap="square" lIns="0" tIns="0" rIns="0" bIns="0" rtlCol="0" anchor="t"/>
-          <a:lstStyle/>
-          <a:p>
-            <a:pPr indent="0" marL="0">
-              <a:buNone/>
-            </a:pPr>
-            <a:r>
-              <a:rPr lang="en-US" sz="850" dirty="0">
-                <a:solidFill>
-                  <a:srgbClr val="1B2333"/>
-                </a:solidFill>
-                <a:latin typeface="Courier New" pitchFamily="34" charset="0"/>
-                <a:ea typeface="Courier New" pitchFamily="34" charset="-122"/>
-                <a:cs typeface="Courier New" pitchFamily="34" charset="-120"/>
-              </a:rPr>
-              <a:t>estaDisponible(), bloquear()</a:t>
-            </a:r>
-            <a:endParaRPr lang="en-US" sz="850" dirty="0"/>
-          </a:p>
-        </p:txBody>
-      </p:sp>
-      <p:sp>
-        <p:nvSpPr>
-          <p:cNvPr id="35" name="Shape 33"/>
-          <p:cNvSpPr/>
-          <p:nvPr/>
-        </p:nvSpPr>
-        <p:spPr>
-          <a:xfrm>
-            <a:off x="5806440" y="1874520"/>
-            <a:ext cx="2880360" cy="557784"/>
-          </a:xfrm>
-          <a:prstGeom prst="rect">
-            <a:avLst/>
-          </a:prstGeom>
-          <a:solidFill>
-            <a:srgbClr val="FFFFFF"/>
-          </a:solidFill>
-          <a:ln w="15875">
-            <a:solidFill>
-              <a:srgbClr val="3A3F4B"/>
-            </a:solidFill>
-            <a:prstDash val="solid"/>
-          </a:ln>
-        </p:spPr>
-      </p:sp>
-      <p:sp>
-        <p:nvSpPr>
-          <p:cNvPr id="36" name="Shape 34"/>
-          <p:cNvSpPr/>
-          <p:nvPr/>
-        </p:nvSpPr>
-        <p:spPr>
-          <a:xfrm>
-            <a:off x="5806440" y="1874520"/>
-            <a:ext cx="2880360" cy="292608"/>
-          </a:xfrm>
-          <a:prstGeom prst="rect">
-            <a:avLst/>
-          </a:prstGeom>
-          <a:solidFill>
-            <a:srgbClr val="3A3F4B"/>
-          </a:solidFill>
-          <a:ln w="15875">
-            <a:solidFill>
-              <a:srgbClr val="3A3F4B"/>
-            </a:solidFill>
-            <a:prstDash val="solid"/>
-          </a:ln>
-        </p:spPr>
-      </p:sp>
-      <p:sp>
-        <p:nvSpPr>
-          <p:cNvPr id="37" name="Text 35"/>
-          <p:cNvSpPr txBox="1"/>
-          <p:nvPr/>
-        </p:nvSpPr>
-        <p:spPr>
-          <a:xfrm>
-            <a:off x="5806440" y="1874520"/>
-            <a:ext cx="2880360" cy="292608"/>
-          </a:xfrm>
-          <a:prstGeom prst="rect">
-            <a:avLst/>
-          </a:prstGeom>
-          <a:noFill/>
-          <a:ln/>
-        </p:spPr>
-        <p:txBody>
-          <a:bodyPr wrap="square" lIns="0" tIns="0" rIns="0" bIns="0" rtlCol="0" anchor="ctr"/>
-          <a:lstStyle/>
-          <a:p>
-            <a:pPr algn="ctr" indent="0" marL="0">
-              <a:buNone/>
-            </a:pPr>
-            <a:r>
-              <a:rPr lang="en-US" sz="1100" b="1" dirty="0">
-                <a:solidFill>
-                  <a:srgbClr val="FFFFFF"/>
-                </a:solidFill>
-                <a:latin typeface="Calibri" pitchFamily="34" charset="0"/>
-                <a:ea typeface="Calibri" pitchFamily="34" charset="-122"/>
-                <a:cs typeface="Calibri" pitchFamily="34" charset="-120"/>
-              </a:rPr>
-              <a:t>ServicioPago</a:t>
-            </a:r>
-            <a:endParaRPr lang="en-US" sz="1400" dirty="0"/>
-          </a:p>
-        </p:txBody>
-      </p:sp>
-      <p:sp>
-        <p:nvSpPr>
-          <p:cNvPr id="38" name="Text 36"/>
-          <p:cNvSpPr txBox="1"/>
-          <p:nvPr/>
-        </p:nvSpPr>
-        <p:spPr>
-          <a:xfrm>
-            <a:off x="5879592" y="2212848"/>
-            <a:ext cx="2770632" cy="219456"/>
-          </a:xfrm>
-          <a:prstGeom prst="rect">
-            <a:avLst/>
-          </a:prstGeom>
-          <a:noFill/>
-          <a:ln/>
-        </p:spPr>
-        <p:txBody>
-          <a:bodyPr wrap="square" lIns="0" tIns="0" rIns="0" bIns="0" rtlCol="0" anchor="t"/>
-          <a:lstStyle/>
-          <a:p>
-            <a:pPr indent="0" marL="0">
-              <a:buNone/>
-            </a:pPr>
-            <a:r>
-              <a:rPr lang="en-US" sz="850" dirty="0">
-                <a:solidFill>
-                  <a:srgbClr val="1B2333"/>
-                </a:solidFill>
-                <a:latin typeface="Courier New" pitchFamily="34" charset="0"/>
-                <a:ea typeface="Courier New" pitchFamily="34" charset="-122"/>
-                <a:cs typeface="Courier New" pitchFamily="34" charset="-120"/>
-              </a:rPr>
-              <a:t>validarMedioPago(), cobrar()</a:t>
-            </a:r>
-            <a:endParaRPr lang="en-US" sz="850" dirty="0"/>
-          </a:p>
-        </p:txBody>
-      </p:sp>
-      <p:sp>
-        <p:nvSpPr>
-          <p:cNvPr id="39" name="Shape 37"/>
-          <p:cNvSpPr/>
-          <p:nvPr/>
-        </p:nvSpPr>
-        <p:spPr>
-          <a:xfrm>
-            <a:off x="5806440" y="2788920"/>
-            <a:ext cx="2880360" cy="557784"/>
-          </a:xfrm>
-          <a:prstGeom prst="rect">
-            <a:avLst/>
-          </a:prstGeom>
-          <a:solidFill>
-            <a:srgbClr val="FFFFFF"/>
-          </a:solidFill>
-          <a:ln w="15875">
-            <a:solidFill>
-              <a:srgbClr val="3A3F4B"/>
-            </a:solidFill>
-            <a:prstDash val="solid"/>
-          </a:ln>
-        </p:spPr>
-      </p:sp>
-      <p:sp>
-        <p:nvSpPr>
-          <p:cNvPr id="40" name="Shape 38"/>
-          <p:cNvSpPr/>
-          <p:nvPr/>
-        </p:nvSpPr>
-        <p:spPr>
-          <a:xfrm>
-            <a:off x="5806440" y="2788920"/>
-            <a:ext cx="2880360" cy="292608"/>
-          </a:xfrm>
-          <a:prstGeom prst="rect">
-            <a:avLst/>
-          </a:prstGeom>
-          <a:solidFill>
-            <a:srgbClr val="3A3F4B"/>
-          </a:solidFill>
-          <a:ln w="15875">
-            <a:solidFill>
-              <a:srgbClr val="3A3F4B"/>
-            </a:solidFill>
-            <a:prstDash val="solid"/>
-          </a:ln>
-        </p:spPr>
-      </p:sp>
-      <p:sp>
-        <p:nvSpPr>
-          <p:cNvPr id="41" name="Text 39"/>
-          <p:cNvSpPr txBox="1"/>
-          <p:nvPr/>
-        </p:nvSpPr>
-        <p:spPr>
-          <a:xfrm>
-            <a:off x="5806440" y="2788920"/>
-            <a:ext cx="2880360" cy="292608"/>
-          </a:xfrm>
-          <a:prstGeom prst="rect">
-            <a:avLst/>
-          </a:prstGeom>
-          <a:noFill/>
-          <a:ln/>
-        </p:spPr>
-        <p:txBody>
-          <a:bodyPr wrap="square" lIns="0" tIns="0" rIns="0" bIns="0" rtlCol="0" anchor="ctr"/>
-          <a:lstStyle/>
-          <a:p>
-            <a:pPr algn="ctr" indent="0" marL="0">
-              <a:buNone/>
-            </a:pPr>
-            <a:r>
-              <a:rPr lang="en-US" sz="1100" b="1" dirty="0">
-                <a:solidFill>
-                  <a:srgbClr val="FFFFFF"/>
-                </a:solidFill>
-                <a:latin typeface="Calibri" pitchFamily="34" charset="0"/>
-                <a:ea typeface="Calibri" pitchFamily="34" charset="-122"/>
-                <a:cs typeface="Calibri" pitchFamily="34" charset="-120"/>
-              </a:rPr>
-              <a:t>ServicioFacturacion</a:t>
-            </a:r>
-            <a:endParaRPr lang="en-US" sz="1400" dirty="0"/>
-          </a:p>
-        </p:txBody>
-      </p:sp>
-      <p:sp>
-        <p:nvSpPr>
-          <p:cNvPr id="42" name="Text 40"/>
-          <p:cNvSpPr txBox="1"/>
-          <p:nvPr/>
-        </p:nvSpPr>
-        <p:spPr>
-          <a:xfrm>
-            <a:off x="5879592" y="3127248"/>
-            <a:ext cx="2770632" cy="219456"/>
-          </a:xfrm>
-          <a:prstGeom prst="rect">
-            <a:avLst/>
-          </a:prstGeom>
-          <a:noFill/>
-          <a:ln/>
-        </p:spPr>
-        <p:txBody>
-          <a:bodyPr wrap="square" lIns="0" tIns="0" rIns="0" bIns="0" rtlCol="0" anchor="t"/>
-          <a:lstStyle/>
-          <a:p>
-            <a:pPr indent="0" marL="0">
-              <a:buNone/>
-            </a:pPr>
-            <a:r>
-              <a:rPr lang="en-US" sz="850" dirty="0">
-                <a:solidFill>
-                  <a:srgbClr val="1B2333"/>
-                </a:solidFill>
-                <a:latin typeface="Courier New" pitchFamily="34" charset="0"/>
-                <a:ea typeface="Courier New" pitchFamily="34" charset="-122"/>
-                <a:cs typeface="Courier New" pitchFamily="34" charset="-120"/>
-              </a:rPr>
-              <a:t>generarFactura()</a:t>
-            </a:r>
-            <a:endParaRPr lang="en-US" sz="850" dirty="0"/>
-          </a:p>
-        </p:txBody>
-      </p:sp>
-      <p:sp>
-        <p:nvSpPr>
-          <p:cNvPr id="43" name="Shape 41"/>
-          <p:cNvSpPr/>
-          <p:nvPr/>
-        </p:nvSpPr>
-        <p:spPr>
-          <a:xfrm>
-            <a:off x="5806440" y="3657600"/>
-            <a:ext cx="2880360" cy="557784"/>
-          </a:xfrm>
-          <a:prstGeom prst="rect">
-            <a:avLst/>
-          </a:prstGeom>
-          <a:solidFill>
-            <a:srgbClr val="FFFFFF"/>
-          </a:solidFill>
-          <a:ln w="15875">
-            <a:solidFill>
-              <a:srgbClr val="3A3F4B"/>
-            </a:solidFill>
-            <a:prstDash val="solid"/>
-          </a:ln>
-        </p:spPr>
-      </p:sp>
-      <p:sp>
-        <p:nvSpPr>
-          <p:cNvPr id="44" name="Shape 42"/>
-          <p:cNvSpPr/>
-          <p:nvPr/>
-        </p:nvSpPr>
-        <p:spPr>
-          <a:xfrm>
-            <a:off x="5806440" y="3657600"/>
-            <a:ext cx="2880360" cy="292608"/>
-          </a:xfrm>
-          <a:prstGeom prst="rect">
-            <a:avLst/>
-          </a:prstGeom>
-          <a:solidFill>
-            <a:srgbClr val="3A3F4B"/>
-          </a:solidFill>
-          <a:ln w="15875">
-            <a:solidFill>
-              <a:srgbClr val="3A3F4B"/>
-            </a:solidFill>
-            <a:prstDash val="solid"/>
-          </a:ln>
-        </p:spPr>
-      </p:sp>
-      <p:sp>
-        <p:nvSpPr>
-          <p:cNvPr id="45" name="Text 43"/>
-          <p:cNvSpPr txBox="1"/>
-          <p:nvPr/>
-        </p:nvSpPr>
-        <p:spPr>
-          <a:xfrm>
-            <a:off x="5806440" y="3657600"/>
-            <a:ext cx="2880360" cy="292608"/>
-          </a:xfrm>
-          <a:prstGeom prst="rect">
-            <a:avLst/>
-          </a:prstGeom>
-          <a:noFill/>
-          <a:ln/>
-        </p:spPr>
-        <p:txBody>
-          <a:bodyPr wrap="square" lIns="0" tIns="0" rIns="0" bIns="0" rtlCol="0" anchor="ctr"/>
-          <a:lstStyle/>
-          <a:p>
-            <a:pPr algn="ctr" indent="0" marL="0">
-              <a:buNone/>
-            </a:pPr>
-            <a:r>
-              <a:rPr lang="en-US" sz="1100" b="1" dirty="0">
-                <a:solidFill>
-                  <a:srgbClr val="FFFFFF"/>
-                </a:solidFill>
-                <a:latin typeface="Calibri" pitchFamily="34" charset="0"/>
-                <a:ea typeface="Calibri" pitchFamily="34" charset="-122"/>
-                <a:cs typeface="Calibri" pitchFamily="34" charset="-120"/>
-              </a:rPr>
-              <a:t>ServicioNotificaciones</a:t>
-            </a:r>
-            <a:endParaRPr lang="en-US" sz="1400" dirty="0"/>
-          </a:p>
-        </p:txBody>
-      </p:sp>
-      <p:sp>
-        <p:nvSpPr>
-          <p:cNvPr id="46" name="Text 44"/>
-          <p:cNvSpPr txBox="1"/>
-          <p:nvPr/>
-        </p:nvSpPr>
-        <p:spPr>
-          <a:xfrm>
-            <a:off x="5879592" y="3995928"/>
-            <a:ext cx="2770632" cy="219456"/>
-          </a:xfrm>
-          <a:prstGeom prst="rect">
-            <a:avLst/>
-          </a:prstGeom>
-          <a:noFill/>
-          <a:ln/>
-        </p:spPr>
-        <p:txBody>
-          <a:bodyPr wrap="square" lIns="0" tIns="0" rIns="0" bIns="0" rtlCol="0" anchor="t"/>
-          <a:lstStyle/>
-          <a:p>
-            <a:pPr indent="0" marL="0">
-              <a:buNone/>
-            </a:pPr>
-            <a:r>
-              <a:rPr lang="en-US" sz="850" dirty="0">
-                <a:solidFill>
-                  <a:srgbClr val="1B2333"/>
-                </a:solidFill>
-                <a:latin typeface="Courier New" pitchFamily="34" charset="0"/>
-                <a:ea typeface="Courier New" pitchFamily="34" charset="-122"/>
-                <a:cs typeface="Courier New" pitchFamily="34" charset="-120"/>
-              </a:rPr>
-              <a:t>enviarConfirmacion()</a:t>
-            </a:r>
-            <a:endParaRPr lang="en-US" sz="850" dirty="0"/>
-          </a:p>
-        </p:txBody>
-      </p:sp>
-      <p:sp>
-        <p:nvSpPr>
-          <p:cNvPr id="47" name="Shape 45"/>
-          <p:cNvSpPr/>
-          <p:nvPr/>
-        </p:nvSpPr>
-        <p:spPr>
-          <a:xfrm>
-            <a:off x="2011680" y="2468880"/>
-            <a:ext cx="548640" cy="137160"/>
-          </a:xfrm>
-          <a:prstGeom prst="line">
-            <a:avLst/>
-          </a:prstGeom>
-          <a:noFill/>
-          <a:ln w="15875">
-            <a:solidFill>
-              <a:srgbClr val="3A3F4B"/>
-            </a:solidFill>
-            <a:prstDash val="solid"/>
-            <a:tailEnd type="arrow"/>
-          </a:ln>
-        </p:spPr>
-      </p:sp>
-      <p:sp>
-        <p:nvSpPr>
-          <p:cNvPr id="48" name="Shape 46"/>
-          <p:cNvSpPr/>
-          <p:nvPr/>
-        </p:nvSpPr>
-        <p:spPr>
-          <a:xfrm flipV="1">
-            <a:off x="5074920" y="1239012"/>
-            <a:ext cx="731520" cy="1367028"/>
-          </a:xfrm>
-          <a:prstGeom prst="line">
-            <a:avLst/>
-          </a:prstGeom>
-          <a:noFill/>
-          <a:ln w="15875">
-            <a:solidFill>
-              <a:srgbClr val="3A3F4B"/>
-            </a:solidFill>
-            <a:prstDash val="solid"/>
-            <a:tailEnd type="arrow"/>
-          </a:ln>
-        </p:spPr>
-      </p:sp>
-      <p:sp>
-        <p:nvSpPr>
-          <p:cNvPr id="49" name="Shape 47"/>
-          <p:cNvSpPr/>
-          <p:nvPr/>
-        </p:nvSpPr>
-        <p:spPr>
-          <a:xfrm flipV="1">
-            <a:off x="5074920" y="2153412"/>
-            <a:ext cx="731520" cy="452628"/>
-          </a:xfrm>
-          <a:prstGeom prst="line">
-            <a:avLst/>
-          </a:prstGeom>
-          <a:noFill/>
-          <a:ln w="15875">
-            <a:solidFill>
-              <a:srgbClr val="3A3F4B"/>
-            </a:solidFill>
-            <a:prstDash val="solid"/>
-            <a:tailEnd type="arrow"/>
-          </a:ln>
-        </p:spPr>
-      </p:sp>
-      <p:sp>
-        <p:nvSpPr>
-          <p:cNvPr id="50" name="Shape 48"/>
-          <p:cNvSpPr/>
-          <p:nvPr/>
-        </p:nvSpPr>
-        <p:spPr>
-          <a:xfrm>
-            <a:off x="5074920" y="2606040"/>
-            <a:ext cx="731520" cy="461772"/>
-          </a:xfrm>
-          <a:prstGeom prst="line">
-            <a:avLst/>
-          </a:prstGeom>
-          <a:noFill/>
-          <a:ln w="15875">
-            <a:solidFill>
-              <a:srgbClr val="3A3F4B"/>
-            </a:solidFill>
-            <a:prstDash val="solid"/>
-            <a:tailEnd type="arrow"/>
-          </a:ln>
-        </p:spPr>
-      </p:sp>
-      <p:sp>
-        <p:nvSpPr>
-          <p:cNvPr id="51" name="Shape 49"/>
-          <p:cNvSpPr/>
-          <p:nvPr/>
-        </p:nvSpPr>
-        <p:spPr>
-          <a:xfrm>
-            <a:off x="5074920" y="2606040"/>
-            <a:ext cx="731520" cy="1330452"/>
-          </a:xfrm>
-          <a:prstGeom prst="line">
-            <a:avLst/>
-          </a:prstGeom>
-          <a:noFill/>
-          <a:ln w="15875">
-            <a:solidFill>
-              <a:srgbClr val="3A3F4B"/>
-            </a:solidFill>
-            <a:prstDash val="solid"/>
-            <a:tailEnd type="arrow"/>
-          </a:ln>
-        </p:spPr>
-      </p:sp>
-      <p:sp>
-        <p:nvSpPr>
-          <p:cNvPr id="52" name="Text 50"/>
-          <p:cNvSpPr txBox="1"/>
-          <p:nvPr/>
-        </p:nvSpPr>
-        <p:spPr>
-          <a:xfrm>
-            <a:off x="457200" y="3246120"/>
-            <a:ext cx="2011680" cy="1097280"/>
-          </a:xfrm>
-          <a:prstGeom prst="rect">
-            <a:avLst/>
-          </a:prstGeom>
-          <a:noFill/>
-          <a:ln/>
-        </p:spPr>
-        <p:txBody>
-          <a:bodyPr wrap="square" lIns="0" tIns="0" rIns="0" bIns="0" rtlCol="0" anchor="t"/>
-          <a:lstStyle/>
-          <a:p>
-            <a:pPr indent="0" marL="0">
-              <a:buNone/>
-            </a:pPr>
-            <a:r>
-              <a:rPr lang="en-US" sz="1000" i="1" dirty="0">
-                <a:solidFill>
-                  <a:srgbClr val="5B6577"/>
-                </a:solidFill>
-                <a:latin typeface="Calibri" pitchFamily="34" charset="0"/>
-                <a:ea typeface="Calibri" pitchFamily="34" charset="-122"/>
-                <a:cs typeface="Calibri" pitchFamily="34" charset="-120"/>
-              </a:rPr>
-              <a:t>Main solo conoce la fachada. Los subsistemas siguen existiendo, pero el cliente ya no los usa.</a:t>
-            </a:r>
-            <a:endParaRPr lang="en-US" sz="1000" dirty="0"/>
-          </a:p>
-        </p:txBody>
-      </p:sp>
-      <p:sp>
-        <p:nvSpPr>
           <p:cNvPr id="53" name="Shape 51"/>
           <p:cNvSpPr/>
           <p:nvPr/>
@@ -10603,6 +9574,30 @@
           </a:p>
         </p:txBody>
       </p:sp>
+      <p:pic>
+        <p:nvPicPr>
+          <p:cNvPr id="57" name="Picture 56" descr="clases.png"/>
+          <p:cNvPicPr>
+            <a:picLocks noChangeAspect="1"/>
+          </p:cNvPicPr>
+          <p:nvPr/>
+        </p:nvPicPr>
+        <p:blipFill>
+          <a:blip r:embed="rId3"/>
+          <a:stretch>
+            <a:fillRect/>
+          </a:stretch>
+        </p:blipFill>
+        <p:spPr>
+          <a:xfrm>
+            <a:off x="457200" y="1073952"/>
+            <a:ext cx="8229600" cy="3365928"/>
+          </a:xfrm>
+          <a:prstGeom prst="rect">
+            <a:avLst/>
+          </a:prstGeom>
+        </p:spPr>
+      </p:pic>
     </p:spTree>
   </p:cSld>
   <p:clrMapOvr>
@@ -19483,862 +18478,6 @@
       </p:sp>
       <p:sp>
         <p:nvSpPr>
-          <p:cNvPr id="23" name="Shape 21"/>
-          <p:cNvSpPr/>
-          <p:nvPr/>
-        </p:nvSpPr>
-        <p:spPr>
-          <a:xfrm>
-            <a:off x="457200" y="3429000"/>
-            <a:ext cx="1554480" cy="722376"/>
-          </a:xfrm>
-          <a:prstGeom prst="rect">
-            <a:avLst/>
-          </a:prstGeom>
-          <a:solidFill>
-            <a:srgbClr val="FFFFFF"/>
-          </a:solidFill>
-          <a:ln w="15875">
-            <a:solidFill>
-              <a:srgbClr val="3A3F4B"/>
-            </a:solidFill>
-            <a:prstDash val="solid"/>
-          </a:ln>
-        </p:spPr>
-      </p:sp>
-      <p:sp>
-        <p:nvSpPr>
-          <p:cNvPr id="24" name="Shape 22"/>
-          <p:cNvSpPr/>
-          <p:nvPr/>
-        </p:nvSpPr>
-        <p:spPr>
-          <a:xfrm>
-            <a:off x="457200" y="3429000"/>
-            <a:ext cx="1554480" cy="457200"/>
-          </a:xfrm>
-          <a:prstGeom prst="rect">
-            <a:avLst/>
-          </a:prstGeom>
-          <a:solidFill>
-            <a:srgbClr val="5BB4F0"/>
-          </a:solidFill>
-          <a:ln w="15875">
-            <a:solidFill>
-              <a:srgbClr val="3A3F4B"/>
-            </a:solidFill>
-            <a:prstDash val="solid"/>
-          </a:ln>
-        </p:spPr>
-      </p:sp>
-      <p:sp>
-        <p:nvSpPr>
-          <p:cNvPr id="25" name="Text 23"/>
-          <p:cNvSpPr txBox="1"/>
-          <p:nvPr/>
-        </p:nvSpPr>
-        <p:spPr>
-          <a:xfrm>
-            <a:off x="457200" y="3429000"/>
-            <a:ext cx="1554480" cy="457200"/>
-          </a:xfrm>
-          <a:prstGeom prst="rect">
-            <a:avLst/>
-          </a:prstGeom>
-          <a:noFill/>
-          <a:ln/>
-        </p:spPr>
-        <p:txBody>
-          <a:bodyPr wrap="square" lIns="0" tIns="0" rIns="0" bIns="0" rtlCol="0" anchor="ctr"/>
-          <a:lstStyle/>
-          <a:p>
-            <a:pPr algn="ctr" indent="0" marL="0">
-              <a:buNone/>
-            </a:pPr>
-            <a:r>
-              <a:rPr lang="en-US" sz="800" i="1" dirty="0">
-                <a:solidFill>
-                  <a:srgbClr val="3A3F4B"/>
-                </a:solidFill>
-                <a:latin typeface="Calibri" pitchFamily="34" charset="0"/>
-                <a:ea typeface="Calibri" pitchFamily="34" charset="-122"/>
-                <a:cs typeface="Calibri" pitchFamily="34" charset="-120"/>
-              </a:rPr>
-              <a:t>«control»</a:t>
-            </a:r>
-            <a:endParaRPr lang="en-US" sz="1400" dirty="0"/>
-          </a:p>
-          <a:p>
-            <a:pPr algn="ctr" indent="0" marL="0">
-              <a:buNone/>
-            </a:pPr>
-            <a:r>
-              <a:rPr lang="en-US" sz="1100" b="1" dirty="0">
-                <a:solidFill>
-                  <a:srgbClr val="3A3F4B"/>
-                </a:solidFill>
-                <a:latin typeface="Calibri" pitchFamily="34" charset="0"/>
-                <a:ea typeface="Calibri" pitchFamily="34" charset="-122"/>
-                <a:cs typeface="Calibri" pitchFamily="34" charset="-120"/>
-              </a:rPr>
-              <a:t>Main</a:t>
-            </a:r>
-            <a:endParaRPr lang="en-US" sz="1400" dirty="0"/>
-          </a:p>
-        </p:txBody>
-      </p:sp>
-      <p:sp>
-        <p:nvSpPr>
-          <p:cNvPr id="26" name="Text 24"/>
-          <p:cNvSpPr txBox="1"/>
-          <p:nvPr/>
-        </p:nvSpPr>
-        <p:spPr>
-          <a:xfrm>
-            <a:off x="530352" y="3931920"/>
-            <a:ext cx="1444752" cy="219456"/>
-          </a:xfrm>
-          <a:prstGeom prst="rect">
-            <a:avLst/>
-          </a:prstGeom>
-          <a:noFill/>
-          <a:ln/>
-        </p:spPr>
-        <p:txBody>
-          <a:bodyPr wrap="square" lIns="0" tIns="0" rIns="0" bIns="0" rtlCol="0" anchor="t"/>
-          <a:lstStyle/>
-          <a:p>
-            <a:pPr indent="0" marL="0">
-              <a:buNone/>
-            </a:pPr>
-            <a:r>
-              <a:rPr lang="en-US" sz="850" dirty="0">
-                <a:solidFill>
-                  <a:srgbClr val="1B2333"/>
-                </a:solidFill>
-                <a:latin typeface="Courier New" pitchFamily="34" charset="0"/>
-                <a:ea typeface="Courier New" pitchFamily="34" charset="-122"/>
-                <a:cs typeface="Courier New" pitchFamily="34" charset="-120"/>
-              </a:rPr>
-              <a:t>(cliente)</a:t>
-            </a:r>
-            <a:endParaRPr lang="en-US" sz="850" dirty="0"/>
-          </a:p>
-        </p:txBody>
-      </p:sp>
-      <p:sp>
-        <p:nvSpPr>
-          <p:cNvPr id="27" name="Shape 25"/>
-          <p:cNvSpPr/>
-          <p:nvPr/>
-        </p:nvSpPr>
-        <p:spPr>
-          <a:xfrm>
-            <a:off x="457200" y="1097280"/>
-            <a:ext cx="2651760" cy="1252728"/>
-          </a:xfrm>
-          <a:prstGeom prst="rect">
-            <a:avLst/>
-          </a:prstGeom>
-          <a:solidFill>
-            <a:srgbClr val="FFFFFF"/>
-          </a:solidFill>
-          <a:ln w="15875">
-            <a:solidFill>
-              <a:srgbClr val="3A3F4B"/>
-            </a:solidFill>
-            <a:prstDash val="solid"/>
-          </a:ln>
-        </p:spPr>
-      </p:sp>
-      <p:sp>
-        <p:nvSpPr>
-          <p:cNvPr id="28" name="Shape 26"/>
-          <p:cNvSpPr/>
-          <p:nvPr/>
-        </p:nvSpPr>
-        <p:spPr>
-          <a:xfrm>
-            <a:off x="457200" y="1097280"/>
-            <a:ext cx="2651760" cy="292608"/>
-          </a:xfrm>
-          <a:prstGeom prst="rect">
-            <a:avLst/>
-          </a:prstGeom>
-          <a:solidFill>
-            <a:srgbClr val="3A3F4B"/>
-          </a:solidFill>
-          <a:ln w="15875">
-            <a:solidFill>
-              <a:srgbClr val="3A3F4B"/>
-            </a:solidFill>
-            <a:prstDash val="solid"/>
-          </a:ln>
-        </p:spPr>
-      </p:sp>
-      <p:sp>
-        <p:nvSpPr>
-          <p:cNvPr id="29" name="Text 27"/>
-          <p:cNvSpPr txBox="1"/>
-          <p:nvPr/>
-        </p:nvSpPr>
-        <p:spPr>
-          <a:xfrm>
-            <a:off x="457200" y="1097280"/>
-            <a:ext cx="2651760" cy="292608"/>
-          </a:xfrm>
-          <a:prstGeom prst="rect">
-            <a:avLst/>
-          </a:prstGeom>
-          <a:noFill/>
-          <a:ln/>
-        </p:spPr>
-        <p:txBody>
-          <a:bodyPr wrap="square" lIns="0" tIns="0" rIns="0" bIns="0" rtlCol="0" anchor="ctr"/>
-          <a:lstStyle/>
-          <a:p>
-            <a:pPr algn="ctr" indent="0" marL="0">
-              <a:buNone/>
-            </a:pPr>
-            <a:r>
-              <a:rPr lang="en-US" sz="1100" b="1" dirty="0">
-                <a:solidFill>
-                  <a:srgbClr val="FFFFFF"/>
-                </a:solidFill>
-                <a:latin typeface="Calibri" pitchFamily="34" charset="0"/>
-                <a:ea typeface="Calibri" pitchFamily="34" charset="-122"/>
-                <a:cs typeface="Calibri" pitchFamily="34" charset="-120"/>
-              </a:rPr>
-              <a:t>BusEnRuta</a:t>
-            </a:r>
-            <a:endParaRPr lang="en-US" sz="1400" dirty="0"/>
-          </a:p>
-        </p:txBody>
-      </p:sp>
-      <p:sp>
-        <p:nvSpPr>
-          <p:cNvPr id="30" name="Text 28"/>
-          <p:cNvSpPr txBox="1"/>
-          <p:nvPr/>
-        </p:nvSpPr>
-        <p:spPr>
-          <a:xfrm>
-            <a:off x="530352" y="1435608"/>
-            <a:ext cx="2542032" cy="914400"/>
-          </a:xfrm>
-          <a:prstGeom prst="rect">
-            <a:avLst/>
-          </a:prstGeom>
-          <a:noFill/>
-          <a:ln/>
-        </p:spPr>
-        <p:txBody>
-          <a:bodyPr wrap="square" lIns="0" tIns="0" rIns="0" bIns="0" rtlCol="0" anchor="t"/>
-          <a:lstStyle/>
-          <a:p>
-            <a:pPr indent="0" marL="0">
-              <a:buNone/>
-            </a:pPr>
-            <a:r>
-              <a:rPr lang="en-US" sz="850" dirty="0">
-                <a:solidFill>
-                  <a:srgbClr val="1B2333"/>
-                </a:solidFill>
-                <a:latin typeface="Courier New" pitchFamily="34" charset="0"/>
-                <a:ea typeface="Courier New" pitchFamily="34" charset="-122"/>
-                <a:cs typeface="Courier New" pitchFamily="34" charset="-120"/>
-              </a:rPr>
-              <a:t>- placa: String</a:t>
-            </a:r>
-            <a:endParaRPr lang="en-US" sz="850" dirty="0"/>
-          </a:p>
-          <a:p>
-            <a:pPr indent="0" marL="0">
-              <a:buNone/>
-            </a:pPr>
-            <a:r>
-              <a:rPr lang="en-US" sz="850" dirty="0">
-                <a:solidFill>
-                  <a:srgbClr val="1B2333"/>
-                </a:solidFill>
-                <a:latin typeface="Courier New" pitchFamily="34" charset="0"/>
-                <a:ea typeface="Courier New" pitchFamily="34" charset="-122"/>
-                <a:cs typeface="Courier New" pitchFamily="34" charset="-120"/>
-              </a:rPr>
-              <a:t>- latitud, longitud</a:t>
-            </a:r>
-            <a:endParaRPr lang="en-US" sz="850" dirty="0"/>
-          </a:p>
-          <a:p>
-            <a:pPr indent="0" marL="0">
-              <a:buNone/>
-            </a:pPr>
-            <a:r>
-              <a:rPr lang="en-US" sz="850" dirty="0">
-                <a:solidFill>
-                  <a:srgbClr val="1B2333"/>
-                </a:solidFill>
-                <a:latin typeface="Courier New" pitchFamily="34" charset="0"/>
-                <a:ea typeface="Courier New" pitchFamily="34" charset="-122"/>
-                <a:cs typeface="Courier New" pitchFamily="34" charset="-120"/>
-              </a:rPr>
-              <a:t>- tipo: TipoBus</a:t>
-            </a:r>
-            <a:endParaRPr lang="en-US" sz="850" dirty="0"/>
-          </a:p>
-          <a:p>
-            <a:pPr indent="0" marL="0">
-              <a:buNone/>
-            </a:pPr>
-            <a:r>
-              <a:rPr lang="en-US" sz="850" dirty="0">
-                <a:solidFill>
-                  <a:srgbClr val="1B2333"/>
-                </a:solidFill>
-                <a:latin typeface="Courier New" pitchFamily="34" charset="0"/>
-                <a:ea typeface="Courier New" pitchFamily="34" charset="-122"/>
-                <a:cs typeface="Courier New" pitchFamily="34" charset="-120"/>
-              </a:rPr>
-              <a:t>+ mover(lat, lon)</a:t>
-            </a:r>
-            <a:endParaRPr lang="en-US" sz="850" dirty="0"/>
-          </a:p>
-          <a:p>
-            <a:pPr indent="0" marL="0">
-              <a:buNone/>
-            </a:pPr>
-            <a:r>
-              <a:rPr lang="en-US" sz="850" dirty="0">
-                <a:solidFill>
-                  <a:srgbClr val="1B2333"/>
-                </a:solidFill>
-                <a:latin typeface="Courier New" pitchFamily="34" charset="0"/>
-                <a:ea typeface="Courier New" pitchFamily="34" charset="-122"/>
-                <a:cs typeface="Courier New" pitchFamily="34" charset="-120"/>
-              </a:rPr>
-              <a:t>+ dibujar()</a:t>
-            </a:r>
-            <a:endParaRPr lang="en-US" sz="850" dirty="0"/>
-          </a:p>
-        </p:txBody>
-      </p:sp>
-      <p:sp>
-        <p:nvSpPr>
-          <p:cNvPr id="31" name="Shape 29"/>
-          <p:cNvSpPr/>
-          <p:nvPr/>
-        </p:nvSpPr>
-        <p:spPr>
-          <a:xfrm>
-            <a:off x="3749040" y="1097280"/>
-            <a:ext cx="2743200" cy="1078992"/>
-          </a:xfrm>
-          <a:prstGeom prst="rect">
-            <a:avLst/>
-          </a:prstGeom>
-          <a:solidFill>
-            <a:srgbClr val="FFFFFF"/>
-          </a:solidFill>
-          <a:ln w="15875">
-            <a:solidFill>
-              <a:srgbClr val="3A3F4B"/>
-            </a:solidFill>
-            <a:prstDash val="solid"/>
-          </a:ln>
-        </p:spPr>
-      </p:sp>
-      <p:sp>
-        <p:nvSpPr>
-          <p:cNvPr id="32" name="Shape 30"/>
-          <p:cNvSpPr/>
-          <p:nvPr/>
-        </p:nvSpPr>
-        <p:spPr>
-          <a:xfrm>
-            <a:off x="3749040" y="1097280"/>
-            <a:ext cx="2743200" cy="292608"/>
-          </a:xfrm>
-          <a:prstGeom prst="rect">
-            <a:avLst/>
-          </a:prstGeom>
-          <a:solidFill>
-            <a:srgbClr val="3A3F4B"/>
-          </a:solidFill>
-          <a:ln w="15875">
-            <a:solidFill>
-              <a:srgbClr val="3A3F4B"/>
-            </a:solidFill>
-            <a:prstDash val="solid"/>
-          </a:ln>
-        </p:spPr>
-      </p:sp>
-      <p:sp>
-        <p:nvSpPr>
-          <p:cNvPr id="33" name="Text 31"/>
-          <p:cNvSpPr txBox="1"/>
-          <p:nvPr/>
-        </p:nvSpPr>
-        <p:spPr>
-          <a:xfrm>
-            <a:off x="3749040" y="1097280"/>
-            <a:ext cx="2743200" cy="292608"/>
-          </a:xfrm>
-          <a:prstGeom prst="rect">
-            <a:avLst/>
-          </a:prstGeom>
-          <a:noFill/>
-          <a:ln/>
-        </p:spPr>
-        <p:txBody>
-          <a:bodyPr wrap="square" lIns="0" tIns="0" rIns="0" bIns="0" rtlCol="0" anchor="ctr"/>
-          <a:lstStyle/>
-          <a:p>
-            <a:pPr algn="ctr" indent="0" marL="0">
-              <a:buNone/>
-            </a:pPr>
-            <a:r>
-              <a:rPr lang="en-US" sz="1100" b="1" dirty="0">
-                <a:solidFill>
-                  <a:srgbClr val="FFFFFF"/>
-                </a:solidFill>
-                <a:latin typeface="Calibri" pitchFamily="34" charset="0"/>
-                <a:ea typeface="Calibri" pitchFamily="34" charset="-122"/>
-                <a:cs typeface="Calibri" pitchFamily="34" charset="-120"/>
-              </a:rPr>
-              <a:t>TipoBus</a:t>
-            </a:r>
-            <a:endParaRPr lang="en-US" sz="1400" dirty="0"/>
-          </a:p>
-        </p:txBody>
-      </p:sp>
-      <p:sp>
-        <p:nvSpPr>
-          <p:cNvPr id="34" name="Text 32"/>
-          <p:cNvSpPr txBox="1"/>
-          <p:nvPr/>
-        </p:nvSpPr>
-        <p:spPr>
-          <a:xfrm>
-            <a:off x="3822192" y="1435608"/>
-            <a:ext cx="2633472" cy="740664"/>
-          </a:xfrm>
-          <a:prstGeom prst="rect">
-            <a:avLst/>
-          </a:prstGeom>
-          <a:noFill/>
-          <a:ln/>
-        </p:spPr>
-        <p:txBody>
-          <a:bodyPr wrap="square" lIns="0" tIns="0" rIns="0" bIns="0" rtlCol="0" anchor="t"/>
-          <a:lstStyle/>
-          <a:p>
-            <a:pPr indent="0" marL="0">
-              <a:buNone/>
-            </a:pPr>
-            <a:r>
-              <a:rPr lang="en-US" sz="850" dirty="0">
-                <a:solidFill>
-                  <a:srgbClr val="1B2333"/>
-                </a:solidFill>
-                <a:latin typeface="Courier New" pitchFamily="34" charset="0"/>
-                <a:ea typeface="Courier New" pitchFamily="34" charset="-122"/>
-                <a:cs typeface="Courier New" pitchFamily="34" charset="-120"/>
-              </a:rPr>
-              <a:t>- marca, modelo: String</a:t>
-            </a:r>
-            <a:endParaRPr lang="en-US" sz="850" dirty="0"/>
-          </a:p>
-          <a:p>
-            <a:pPr indent="0" marL="0">
-              <a:buNone/>
-            </a:pPr>
-            <a:r>
-              <a:rPr lang="en-US" sz="850" dirty="0">
-                <a:solidFill>
-                  <a:srgbClr val="1B2333"/>
-                </a:solidFill>
-                <a:latin typeface="Courier New" pitchFamily="34" charset="0"/>
-                <a:ea typeface="Courier New" pitchFamily="34" charset="-122"/>
-                <a:cs typeface="Courier New" pitchFamily="34" charset="-120"/>
-              </a:rPr>
-              <a:t>- capacidad: int</a:t>
-            </a:r>
-            <a:endParaRPr lang="en-US" sz="850" dirty="0"/>
-          </a:p>
-          <a:p>
-            <a:pPr indent="0" marL="0">
-              <a:buNone/>
-            </a:pPr>
-            <a:r>
-              <a:rPr lang="en-US" sz="850" dirty="0">
-                <a:solidFill>
-                  <a:srgbClr val="1B2333"/>
-                </a:solidFill>
-                <a:latin typeface="Courier New" pitchFamily="34" charset="0"/>
-                <a:ea typeface="Courier New" pitchFamily="34" charset="-122"/>
-                <a:cs typeface="Courier New" pitchFamily="34" charset="-120"/>
-              </a:rPr>
-              <a:t>- modelo3D: byte[]</a:t>
-            </a:r>
-            <a:endParaRPr lang="en-US" sz="850" dirty="0"/>
-          </a:p>
-          <a:p>
-            <a:pPr indent="0" marL="0">
-              <a:buNone/>
-            </a:pPr>
-            <a:r>
-              <a:rPr lang="en-US" sz="850" dirty="0">
-                <a:solidFill>
-                  <a:srgbClr val="1B2333"/>
-                </a:solidFill>
-                <a:latin typeface="Courier New" pitchFamily="34" charset="0"/>
-                <a:ea typeface="Courier New" pitchFamily="34" charset="-122"/>
-                <a:cs typeface="Courier New" pitchFamily="34" charset="-120"/>
-              </a:rPr>
-              <a:t>+ dibujar(placa, lat, lon)</a:t>
-            </a:r>
-            <a:endParaRPr lang="en-US" sz="850" dirty="0"/>
-          </a:p>
-        </p:txBody>
-      </p:sp>
-      <p:sp>
-        <p:nvSpPr>
-          <p:cNvPr id="35" name="Shape 33"/>
-          <p:cNvSpPr/>
-          <p:nvPr/>
-        </p:nvSpPr>
-        <p:spPr>
-          <a:xfrm>
-            <a:off x="3749040" y="3200400"/>
-            <a:ext cx="2743200" cy="905256"/>
-          </a:xfrm>
-          <a:prstGeom prst="rect">
-            <a:avLst/>
-          </a:prstGeom>
-          <a:solidFill>
-            <a:srgbClr val="FFFFFF"/>
-          </a:solidFill>
-          <a:ln w="15875">
-            <a:solidFill>
-              <a:srgbClr val="3A3F4B"/>
-            </a:solidFill>
-            <a:prstDash val="solid"/>
-          </a:ln>
-        </p:spPr>
-      </p:sp>
-      <p:sp>
-        <p:nvSpPr>
-          <p:cNvPr id="36" name="Shape 34"/>
-          <p:cNvSpPr/>
-          <p:nvPr/>
-        </p:nvSpPr>
-        <p:spPr>
-          <a:xfrm>
-            <a:off x="3749040" y="3200400"/>
-            <a:ext cx="2743200" cy="292608"/>
-          </a:xfrm>
-          <a:prstGeom prst="rect">
-            <a:avLst/>
-          </a:prstGeom>
-          <a:solidFill>
-            <a:srgbClr val="3A3F4B"/>
-          </a:solidFill>
-          <a:ln w="15875">
-            <a:solidFill>
-              <a:srgbClr val="3A3F4B"/>
-            </a:solidFill>
-            <a:prstDash val="solid"/>
-          </a:ln>
-        </p:spPr>
-      </p:sp>
-      <p:sp>
-        <p:nvSpPr>
-          <p:cNvPr id="37" name="Text 35"/>
-          <p:cNvSpPr txBox="1"/>
-          <p:nvPr/>
-        </p:nvSpPr>
-        <p:spPr>
-          <a:xfrm>
-            <a:off x="3749040" y="3200400"/>
-            <a:ext cx="2743200" cy="292608"/>
-          </a:xfrm>
-          <a:prstGeom prst="rect">
-            <a:avLst/>
-          </a:prstGeom>
-          <a:noFill/>
-          <a:ln/>
-        </p:spPr>
-        <p:txBody>
-          <a:bodyPr wrap="square" lIns="0" tIns="0" rIns="0" bIns="0" rtlCol="0" anchor="ctr"/>
-          <a:lstStyle/>
-          <a:p>
-            <a:pPr algn="ctr" indent="0" marL="0">
-              <a:buNone/>
-            </a:pPr>
-            <a:r>
-              <a:rPr lang="en-US" sz="1100" b="1" dirty="0">
-                <a:solidFill>
-                  <a:srgbClr val="FFFFFF"/>
-                </a:solidFill>
-                <a:latin typeface="Calibri" pitchFamily="34" charset="0"/>
-                <a:ea typeface="Calibri" pitchFamily="34" charset="-122"/>
-                <a:cs typeface="Calibri" pitchFamily="34" charset="-120"/>
-              </a:rPr>
-              <a:t>TipoBusFactory</a:t>
-            </a:r>
-            <a:endParaRPr lang="en-US" sz="1400" dirty="0"/>
-          </a:p>
-        </p:txBody>
-      </p:sp>
-      <p:sp>
-        <p:nvSpPr>
-          <p:cNvPr id="38" name="Text 36"/>
-          <p:cNvSpPr txBox="1"/>
-          <p:nvPr/>
-        </p:nvSpPr>
-        <p:spPr>
-          <a:xfrm>
-            <a:off x="3822192" y="3538728"/>
-            <a:ext cx="2633472" cy="566928"/>
-          </a:xfrm>
-          <a:prstGeom prst="rect">
-            <a:avLst/>
-          </a:prstGeom>
-          <a:noFill/>
-          <a:ln/>
-        </p:spPr>
-        <p:txBody>
-          <a:bodyPr wrap="square" lIns="0" tIns="0" rIns="0" bIns="0" rtlCol="0" anchor="t"/>
-          <a:lstStyle/>
-          <a:p>
-            <a:pPr indent="0" marL="0">
-              <a:buNone/>
-            </a:pPr>
-            <a:r>
-              <a:rPr lang="en-US" sz="850" dirty="0">
-                <a:solidFill>
-                  <a:srgbClr val="1B2333"/>
-                </a:solidFill>
-                <a:latin typeface="Courier New" pitchFamily="34" charset="0"/>
-                <a:ea typeface="Courier New" pitchFamily="34" charset="-122"/>
-                <a:cs typeface="Courier New" pitchFamily="34" charset="-120"/>
-              </a:rPr>
-              <a:t>- CACHE: Map&lt;String,TipoBus&gt;</a:t>
-            </a:r>
-            <a:endParaRPr lang="en-US" sz="850" dirty="0"/>
-          </a:p>
-          <a:p>
-            <a:pPr indent="0" marL="0">
-              <a:buNone/>
-            </a:pPr>
-            <a:r>
-              <a:rPr lang="en-US" sz="850" dirty="0">
-                <a:solidFill>
-                  <a:srgbClr val="1B2333"/>
-                </a:solidFill>
-                <a:latin typeface="Courier New" pitchFamily="34" charset="0"/>
-                <a:ea typeface="Courier New" pitchFamily="34" charset="-122"/>
-                <a:cs typeface="Courier New" pitchFamily="34" charset="-120"/>
-              </a:rPr>
-              <a:t>+ obtener(marca, modelo,</a:t>
-            </a:r>
-            <a:endParaRPr lang="en-US" sz="850" dirty="0"/>
-          </a:p>
-          <a:p>
-            <a:pPr indent="0" marL="0">
-              <a:buNone/>
-            </a:pPr>
-            <a:r>
-              <a:rPr lang="en-US" sz="850" dirty="0">
-                <a:solidFill>
-                  <a:srgbClr val="1B2333"/>
-                </a:solidFill>
-                <a:latin typeface="Courier New" pitchFamily="34" charset="0"/>
-                <a:ea typeface="Courier New" pitchFamily="34" charset="-122"/>
-                <a:cs typeface="Courier New" pitchFamily="34" charset="-120"/>
-              </a:rPr>
-              <a:t>          capacidad): TipoBus</a:t>
-            </a:r>
-            <a:endParaRPr lang="en-US" sz="850" dirty="0"/>
-          </a:p>
-        </p:txBody>
-      </p:sp>
-      <p:sp>
-        <p:nvSpPr>
-          <p:cNvPr id="39" name="Shape 37"/>
-          <p:cNvSpPr/>
-          <p:nvPr/>
-        </p:nvSpPr>
-        <p:spPr>
-          <a:xfrm>
-            <a:off x="3108960" y="1783080"/>
-            <a:ext cx="640080" cy="0"/>
-          </a:xfrm>
-          <a:prstGeom prst="line">
-            <a:avLst/>
-          </a:prstGeom>
-          <a:noFill/>
-          <a:ln w="15875">
-            <a:solidFill>
-              <a:srgbClr val="3A3F4B"/>
-            </a:solidFill>
-            <a:prstDash val="solid"/>
-            <a:tailEnd type="arrow"/>
-          </a:ln>
-        </p:spPr>
-      </p:sp>
-      <p:sp>
-        <p:nvSpPr>
-          <p:cNvPr id="40" name="Text 38"/>
-          <p:cNvSpPr txBox="1"/>
-          <p:nvPr/>
-        </p:nvSpPr>
-        <p:spPr>
-          <a:xfrm>
-            <a:off x="3127248" y="1508760"/>
-            <a:ext cx="640080" cy="182880"/>
-          </a:xfrm>
-          <a:prstGeom prst="rect">
-            <a:avLst/>
-          </a:prstGeom>
-          <a:noFill/>
-          <a:ln/>
-        </p:spPr>
-        <p:txBody>
-          <a:bodyPr wrap="square" lIns="0" tIns="0" rIns="0" bIns="0" rtlCol="0" anchor="t"/>
-          <a:lstStyle/>
-          <a:p>
-            <a:pPr indent="0" marL="0">
-              <a:buNone/>
-            </a:pPr>
-            <a:r>
-              <a:rPr lang="en-US" sz="850" i="1" dirty="0">
-                <a:solidFill>
-                  <a:srgbClr val="5B6577"/>
-                </a:solidFill>
-                <a:latin typeface="Calibri" pitchFamily="34" charset="0"/>
-                <a:ea typeface="Calibri" pitchFamily="34" charset="-122"/>
-                <a:cs typeface="Calibri" pitchFamily="34" charset="-120"/>
-              </a:rPr>
-              <a:t>comparte</a:t>
-            </a:r>
-            <a:endParaRPr lang="en-US" sz="850" dirty="0"/>
-          </a:p>
-        </p:txBody>
-      </p:sp>
-      <p:sp>
-        <p:nvSpPr>
-          <p:cNvPr id="41" name="Shape 39"/>
-          <p:cNvSpPr/>
-          <p:nvPr/>
-        </p:nvSpPr>
-        <p:spPr>
-          <a:xfrm flipV="1">
-            <a:off x="5120640" y="2176272"/>
-            <a:ext cx="0" cy="1024128"/>
-          </a:xfrm>
-          <a:prstGeom prst="line">
-            <a:avLst/>
-          </a:prstGeom>
-          <a:noFill/>
-          <a:ln w="15875">
-            <a:solidFill>
-              <a:srgbClr val="3A3F4B"/>
-            </a:solidFill>
-            <a:prstDash val="dash"/>
-            <a:tailEnd type="arrow"/>
-          </a:ln>
-        </p:spPr>
-      </p:sp>
-      <p:sp>
-        <p:nvSpPr>
-          <p:cNvPr id="42" name="Text 40"/>
-          <p:cNvSpPr txBox="1"/>
-          <p:nvPr/>
-        </p:nvSpPr>
-        <p:spPr>
-          <a:xfrm>
-            <a:off x="5193792" y="2880360"/>
-            <a:ext cx="1280160" cy="182880"/>
-          </a:xfrm>
-          <a:prstGeom prst="rect">
-            <a:avLst/>
-          </a:prstGeom>
-          <a:noFill/>
-          <a:ln/>
-        </p:spPr>
-        <p:txBody>
-          <a:bodyPr wrap="square" lIns="0" tIns="0" rIns="0" bIns="0" rtlCol="0" anchor="t"/>
-          <a:lstStyle/>
-          <a:p>
-            <a:pPr indent="0" marL="0">
-              <a:buNone/>
-            </a:pPr>
-            <a:r>
-              <a:rPr lang="en-US" sz="850" i="1" dirty="0">
-                <a:solidFill>
-                  <a:srgbClr val="5B6577"/>
-                </a:solidFill>
-                <a:latin typeface="Calibri" pitchFamily="34" charset="0"/>
-                <a:ea typeface="Calibri" pitchFamily="34" charset="-122"/>
-                <a:cs typeface="Calibri" pitchFamily="34" charset="-120"/>
-              </a:rPr>
-              <a:t>crea / reutiliza</a:t>
-            </a:r>
-            <a:endParaRPr lang="en-US" sz="850" dirty="0"/>
-          </a:p>
-        </p:txBody>
-      </p:sp>
-      <p:sp>
-        <p:nvSpPr>
-          <p:cNvPr id="43" name="Shape 41"/>
-          <p:cNvSpPr/>
-          <p:nvPr/>
-        </p:nvSpPr>
-        <p:spPr>
-          <a:xfrm flipV="1">
-            <a:off x="1234440" y="2350008"/>
-            <a:ext cx="0" cy="1078992"/>
-          </a:xfrm>
-          <a:prstGeom prst="line">
-            <a:avLst/>
-          </a:prstGeom>
-          <a:noFill/>
-          <a:ln w="15875">
-            <a:solidFill>
-              <a:srgbClr val="3A3F4B"/>
-            </a:solidFill>
-            <a:prstDash val="solid"/>
-            <a:tailEnd type="arrow"/>
-          </a:ln>
-        </p:spPr>
-      </p:sp>
-      <p:sp>
-        <p:nvSpPr>
-          <p:cNvPr id="44" name="Shape 42"/>
-          <p:cNvSpPr/>
-          <p:nvPr/>
-        </p:nvSpPr>
-        <p:spPr>
-          <a:xfrm flipV="1">
-            <a:off x="2011680" y="3749040"/>
-            <a:ext cx="1737360" cy="45720"/>
-          </a:xfrm>
-          <a:prstGeom prst="line">
-            <a:avLst/>
-          </a:prstGeom>
-          <a:noFill/>
-          <a:ln w="15875">
-            <a:solidFill>
-              <a:srgbClr val="3A3F4B"/>
-            </a:solidFill>
-            <a:prstDash val="solid"/>
-            <a:tailEnd type="arrow"/>
-          </a:ln>
-        </p:spPr>
-      </p:sp>
-      <p:sp>
-        <p:nvSpPr>
           <p:cNvPr id="45" name="Shape 43"/>
           <p:cNvSpPr/>
           <p:nvPr/>
@@ -20772,6 +18911,30 @@
           </a:p>
         </p:txBody>
       </p:sp>
+      <p:pic>
+        <p:nvPicPr>
+          <p:cNvPr id="57" name="Picture 56" descr="clases.png"/>
+          <p:cNvPicPr>
+            <a:picLocks noChangeAspect="1"/>
+          </p:cNvPicPr>
+          <p:nvPr/>
+        </p:nvPicPr>
+        <p:blipFill>
+          <a:blip r:embed="rId3"/>
+          <a:stretch>
+            <a:fillRect/>
+          </a:stretch>
+        </p:blipFill>
+        <p:spPr>
+          <a:xfrm>
+            <a:off x="1287827" y="960120"/>
+            <a:ext cx="4648105" cy="3593592"/>
+          </a:xfrm>
+          <a:prstGeom prst="rect">
+            <a:avLst/>
+          </a:prstGeom>
+        </p:spPr>
+      </p:pic>
     </p:spTree>
   </p:cSld>
   <p:clrMapOvr>
@@ -28559,755 +26722,6 @@
       </p:sp>
       <p:sp>
         <p:nvSpPr>
-          <p:cNvPr id="23" name="Shape 21"/>
-          <p:cNvSpPr/>
-          <p:nvPr/>
-        </p:nvSpPr>
-        <p:spPr>
-          <a:xfrm>
-            <a:off x="457200" y="960120"/>
-            <a:ext cx="1737360" cy="722376"/>
-          </a:xfrm>
-          <a:prstGeom prst="rect">
-            <a:avLst/>
-          </a:prstGeom>
-          <a:solidFill>
-            <a:srgbClr val="FFFFFF"/>
-          </a:solidFill>
-          <a:ln w="15875">
-            <a:solidFill>
-              <a:srgbClr val="3A3F4B"/>
-            </a:solidFill>
-            <a:prstDash val="solid"/>
-          </a:ln>
-        </p:spPr>
-      </p:sp>
-      <p:sp>
-        <p:nvSpPr>
-          <p:cNvPr id="24" name="Shape 22"/>
-          <p:cNvSpPr/>
-          <p:nvPr/>
-        </p:nvSpPr>
-        <p:spPr>
-          <a:xfrm>
-            <a:off x="457200" y="960120"/>
-            <a:ext cx="1737360" cy="457200"/>
-          </a:xfrm>
-          <a:prstGeom prst="rect">
-            <a:avLst/>
-          </a:prstGeom>
-          <a:solidFill>
-            <a:srgbClr val="5BB4F0"/>
-          </a:solidFill>
-          <a:ln w="15875">
-            <a:solidFill>
-              <a:srgbClr val="3A3F4B"/>
-            </a:solidFill>
-            <a:prstDash val="solid"/>
-          </a:ln>
-        </p:spPr>
-      </p:sp>
-      <p:sp>
-        <p:nvSpPr>
-          <p:cNvPr id="25" name="Text 23"/>
-          <p:cNvSpPr txBox="1"/>
-          <p:nvPr/>
-        </p:nvSpPr>
-        <p:spPr>
-          <a:xfrm>
-            <a:off x="457200" y="960120"/>
-            <a:ext cx="1737360" cy="457200"/>
-          </a:xfrm>
-          <a:prstGeom prst="rect">
-            <a:avLst/>
-          </a:prstGeom>
-          <a:noFill/>
-          <a:ln/>
-        </p:spPr>
-        <p:txBody>
-          <a:bodyPr wrap="square" lIns="0" tIns="0" rIns="0" bIns="0" rtlCol="0" anchor="ctr"/>
-          <a:lstStyle/>
-          <a:p>
-            <a:pPr algn="ctr" indent="0" marL="0">
-              <a:buNone/>
-            </a:pPr>
-            <a:r>
-              <a:rPr lang="en-US" sz="800" i="1" dirty="0">
-                <a:solidFill>
-                  <a:srgbClr val="3A3F4B"/>
-                </a:solidFill>
-                <a:latin typeface="Calibri" pitchFamily="34" charset="0"/>
-                <a:ea typeface="Calibri" pitchFamily="34" charset="-122"/>
-                <a:cs typeface="Calibri" pitchFamily="34" charset="-120"/>
-              </a:rPr>
-              <a:t>«control»</a:t>
-            </a:r>
-            <a:endParaRPr lang="en-US" sz="1400" dirty="0"/>
-          </a:p>
-          <a:p>
-            <a:pPr algn="ctr" indent="0" marL="0">
-              <a:buNone/>
-            </a:pPr>
-            <a:r>
-              <a:rPr lang="en-US" sz="1100" b="1" dirty="0">
-                <a:solidFill>
-                  <a:srgbClr val="3A3F4B"/>
-                </a:solidFill>
-                <a:latin typeface="Calibri" pitchFamily="34" charset="0"/>
-                <a:ea typeface="Calibri" pitchFamily="34" charset="-122"/>
-                <a:cs typeface="Calibri" pitchFamily="34" charset="-120"/>
-              </a:rPr>
-              <a:t>Main</a:t>
-            </a:r>
-            <a:endParaRPr lang="en-US" sz="1400" dirty="0"/>
-          </a:p>
-        </p:txBody>
-      </p:sp>
-      <p:sp>
-        <p:nvSpPr>
-          <p:cNvPr id="26" name="Text 24"/>
-          <p:cNvSpPr txBox="1"/>
-          <p:nvPr/>
-        </p:nvSpPr>
-        <p:spPr>
-          <a:xfrm>
-            <a:off x="530352" y="1463040"/>
-            <a:ext cx="1627632" cy="219456"/>
-          </a:xfrm>
-          <a:prstGeom prst="rect">
-            <a:avLst/>
-          </a:prstGeom>
-          <a:noFill/>
-          <a:ln/>
-        </p:spPr>
-        <p:txBody>
-          <a:bodyPr wrap="square" lIns="0" tIns="0" rIns="0" bIns="0" rtlCol="0" anchor="t"/>
-          <a:lstStyle/>
-          <a:p>
-            <a:pPr indent="0" marL="0">
-              <a:buNone/>
-            </a:pPr>
-            <a:r>
-              <a:rPr lang="en-US" sz="850" dirty="0">
-                <a:solidFill>
-                  <a:srgbClr val="1B2333"/>
-                </a:solidFill>
-                <a:latin typeface="Courier New" pitchFamily="34" charset="0"/>
-                <a:ea typeface="Courier New" pitchFamily="34" charset="-122"/>
-                <a:cs typeface="Courier New" pitchFamily="34" charset="-120"/>
-              </a:rPr>
-              <a:t>(cliente)</a:t>
-            </a:r>
-            <a:endParaRPr lang="en-US" sz="850" dirty="0"/>
-          </a:p>
-        </p:txBody>
-      </p:sp>
-      <p:sp>
-        <p:nvSpPr>
-          <p:cNvPr id="27" name="Shape 25"/>
-          <p:cNvSpPr/>
-          <p:nvPr/>
-        </p:nvSpPr>
-        <p:spPr>
-          <a:xfrm>
-            <a:off x="3017520" y="960120"/>
-            <a:ext cx="3291840" cy="722376"/>
-          </a:xfrm>
-          <a:prstGeom prst="rect">
-            <a:avLst/>
-          </a:prstGeom>
-          <a:solidFill>
-            <a:srgbClr val="FFFFFF"/>
-          </a:solidFill>
-          <a:ln w="15875">
-            <a:solidFill>
-              <a:srgbClr val="3A3F4B"/>
-            </a:solidFill>
-            <a:prstDash val="solid"/>
-          </a:ln>
-        </p:spPr>
-      </p:sp>
-      <p:sp>
-        <p:nvSpPr>
-          <p:cNvPr id="28" name="Shape 26"/>
-          <p:cNvSpPr/>
-          <p:nvPr/>
-        </p:nvSpPr>
-        <p:spPr>
-          <a:xfrm>
-            <a:off x="3017520" y="960120"/>
-            <a:ext cx="3291840" cy="457200"/>
-          </a:xfrm>
-          <a:prstGeom prst="rect">
-            <a:avLst/>
-          </a:prstGeom>
-          <a:solidFill>
-            <a:srgbClr val="3A3F4B"/>
-          </a:solidFill>
-          <a:ln w="15875">
-            <a:solidFill>
-              <a:srgbClr val="3A3F4B"/>
-            </a:solidFill>
-            <a:prstDash val="solid"/>
-          </a:ln>
-        </p:spPr>
-      </p:sp>
-      <p:sp>
-        <p:nvSpPr>
-          <p:cNvPr id="29" name="Text 27"/>
-          <p:cNvSpPr txBox="1"/>
-          <p:nvPr/>
-        </p:nvSpPr>
-        <p:spPr>
-          <a:xfrm>
-            <a:off x="3017520" y="960120"/>
-            <a:ext cx="3291840" cy="457200"/>
-          </a:xfrm>
-          <a:prstGeom prst="rect">
-            <a:avLst/>
-          </a:prstGeom>
-          <a:noFill/>
-          <a:ln/>
-        </p:spPr>
-        <p:txBody>
-          <a:bodyPr wrap="square" lIns="0" tIns="0" rIns="0" bIns="0" rtlCol="0" anchor="ctr"/>
-          <a:lstStyle/>
-          <a:p>
-            <a:pPr algn="ctr" indent="0" marL="0">
-              <a:buNone/>
-            </a:pPr>
-            <a:r>
-              <a:rPr lang="en-US" sz="800" i="1" dirty="0">
-                <a:solidFill>
-                  <a:srgbClr val="CADCFC"/>
-                </a:solidFill>
-                <a:latin typeface="Calibri" pitchFamily="34" charset="0"/>
-                <a:ea typeface="Calibri" pitchFamily="34" charset="-122"/>
-                <a:cs typeface="Calibri" pitchFamily="34" charset="-120"/>
-              </a:rPr>
-              <a:t>«interface»</a:t>
-            </a:r>
-            <a:endParaRPr lang="en-US" sz="1400" dirty="0"/>
-          </a:p>
-          <a:p>
-            <a:pPr algn="ctr" indent="0" marL="0">
-              <a:buNone/>
-            </a:pPr>
-            <a:r>
-              <a:rPr lang="en-US" sz="1100" b="1" dirty="0">
-                <a:solidFill>
-                  <a:srgbClr val="FFFFFF"/>
-                </a:solidFill>
-                <a:latin typeface="Calibri" pitchFamily="34" charset="0"/>
-                <a:ea typeface="Calibri" pitchFamily="34" charset="-122"/>
-                <a:cs typeface="Calibri" pitchFamily="34" charset="-120"/>
-              </a:rPr>
-              <a:t>RepositorioReportes</a:t>
-            </a:r>
-            <a:endParaRPr lang="en-US" sz="1400" dirty="0"/>
-          </a:p>
-        </p:txBody>
-      </p:sp>
-      <p:sp>
-        <p:nvSpPr>
-          <p:cNvPr id="30" name="Text 28"/>
-          <p:cNvSpPr txBox="1"/>
-          <p:nvPr/>
-        </p:nvSpPr>
-        <p:spPr>
-          <a:xfrm>
-            <a:off x="3090672" y="1463040"/>
-            <a:ext cx="3182112" cy="219456"/>
-          </a:xfrm>
-          <a:prstGeom prst="rect">
-            <a:avLst/>
-          </a:prstGeom>
-          <a:noFill/>
-          <a:ln/>
-        </p:spPr>
-        <p:txBody>
-          <a:bodyPr wrap="square" lIns="0" tIns="0" rIns="0" bIns="0" rtlCol="0" anchor="t"/>
-          <a:lstStyle/>
-          <a:p>
-            <a:pPr indent="0" marL="0">
-              <a:buNone/>
-            </a:pPr>
-            <a:r>
-              <a:rPr lang="en-US" sz="850" dirty="0">
-                <a:solidFill>
-                  <a:srgbClr val="1B2333"/>
-                </a:solidFill>
-                <a:latin typeface="Courier New" pitchFamily="34" charset="0"/>
-                <a:ea typeface="Courier New" pitchFamily="34" charset="-122"/>
-                <a:cs typeface="Courier New" pitchFamily="34" charset="-120"/>
-              </a:rPr>
-              <a:t>+ obtenerReporte(id): String</a:t>
-            </a:r>
-            <a:endParaRPr lang="en-US" sz="850" dirty="0"/>
-          </a:p>
-        </p:txBody>
-      </p:sp>
-      <p:sp>
-        <p:nvSpPr>
-          <p:cNvPr id="31" name="Shape 29"/>
-          <p:cNvSpPr/>
-          <p:nvPr/>
-        </p:nvSpPr>
-        <p:spPr>
-          <a:xfrm>
-            <a:off x="457200" y="3063240"/>
-            <a:ext cx="2743200" cy="731520"/>
-          </a:xfrm>
-          <a:prstGeom prst="rect">
-            <a:avLst/>
-          </a:prstGeom>
-          <a:solidFill>
-            <a:srgbClr val="FFFFFF"/>
-          </a:solidFill>
-          <a:ln w="15875">
-            <a:solidFill>
-              <a:srgbClr val="3A3F4B"/>
-            </a:solidFill>
-            <a:prstDash val="solid"/>
-          </a:ln>
-        </p:spPr>
-      </p:sp>
-      <p:sp>
-        <p:nvSpPr>
-          <p:cNvPr id="32" name="Shape 30"/>
-          <p:cNvSpPr/>
-          <p:nvPr/>
-        </p:nvSpPr>
-        <p:spPr>
-          <a:xfrm>
-            <a:off x="457200" y="3063240"/>
-            <a:ext cx="2743200" cy="292608"/>
-          </a:xfrm>
-          <a:prstGeom prst="rect">
-            <a:avLst/>
-          </a:prstGeom>
-          <a:solidFill>
-            <a:srgbClr val="3A3F4B"/>
-          </a:solidFill>
-          <a:ln w="15875">
-            <a:solidFill>
-              <a:srgbClr val="3A3F4B"/>
-            </a:solidFill>
-            <a:prstDash val="solid"/>
-          </a:ln>
-        </p:spPr>
-      </p:sp>
-      <p:sp>
-        <p:nvSpPr>
-          <p:cNvPr id="33" name="Text 31"/>
-          <p:cNvSpPr txBox="1"/>
-          <p:nvPr/>
-        </p:nvSpPr>
-        <p:spPr>
-          <a:xfrm>
-            <a:off x="457200" y="3063240"/>
-            <a:ext cx="2743200" cy="292608"/>
-          </a:xfrm>
-          <a:prstGeom prst="rect">
-            <a:avLst/>
-          </a:prstGeom>
-          <a:noFill/>
-          <a:ln/>
-        </p:spPr>
-        <p:txBody>
-          <a:bodyPr wrap="square" lIns="0" tIns="0" rIns="0" bIns="0" rtlCol="0" anchor="ctr"/>
-          <a:lstStyle/>
-          <a:p>
-            <a:pPr algn="ctr" indent="0" marL="0">
-              <a:buNone/>
-            </a:pPr>
-            <a:r>
-              <a:rPr lang="en-US" sz="1100" b="1" dirty="0">
-                <a:solidFill>
-                  <a:srgbClr val="FFFFFF"/>
-                </a:solidFill>
-                <a:latin typeface="Calibri" pitchFamily="34" charset="0"/>
-                <a:ea typeface="Calibri" pitchFamily="34" charset="-122"/>
-                <a:cs typeface="Calibri" pitchFamily="34" charset="-120"/>
-              </a:rPr>
-              <a:t>RepositorioReportesReal</a:t>
-            </a:r>
-            <a:endParaRPr lang="en-US" sz="1400" dirty="0"/>
-          </a:p>
-        </p:txBody>
-      </p:sp>
-      <p:sp>
-        <p:nvSpPr>
-          <p:cNvPr id="34" name="Text 32"/>
-          <p:cNvSpPr txBox="1"/>
-          <p:nvPr/>
-        </p:nvSpPr>
-        <p:spPr>
-          <a:xfrm>
-            <a:off x="530352" y="3401568"/>
-            <a:ext cx="2633472" cy="393192"/>
-          </a:xfrm>
-          <a:prstGeom prst="rect">
-            <a:avLst/>
-          </a:prstGeom>
-          <a:noFill/>
-          <a:ln/>
-        </p:spPr>
-        <p:txBody>
-          <a:bodyPr wrap="square" lIns="0" tIns="0" rIns="0" bIns="0" rtlCol="0" anchor="t"/>
-          <a:lstStyle/>
-          <a:p>
-            <a:pPr indent="0" marL="0">
-              <a:buNone/>
-            </a:pPr>
-            <a:r>
-              <a:rPr lang="en-US" sz="850" dirty="0">
-                <a:solidFill>
-                  <a:srgbClr val="1B2333"/>
-                </a:solidFill>
-                <a:latin typeface="Courier New" pitchFamily="34" charset="0"/>
-                <a:ea typeface="Courier New" pitchFamily="34" charset="-122"/>
-                <a:cs typeface="Courier New" pitchFamily="34" charset="-120"/>
-              </a:rPr>
-              <a:t>+ obtenerReporte(id)</a:t>
-            </a:r>
-            <a:endParaRPr lang="en-US" sz="850" dirty="0"/>
-          </a:p>
-          <a:p>
-            <a:pPr indent="0" marL="0">
-              <a:buNone/>
-            </a:pPr>
-            <a:r>
-              <a:rPr lang="en-US" sz="850" dirty="0">
-                <a:solidFill>
-                  <a:srgbClr val="1B2333"/>
-                </a:solidFill>
-                <a:latin typeface="Courier New" pitchFamily="34" charset="0"/>
-                <a:ea typeface="Courier New" pitchFamily="34" charset="-122"/>
-                <a:cs typeface="Courier New" pitchFamily="34" charset="-120"/>
-              </a:rPr>
-              <a:t>(consulta lenta a la BD)</a:t>
-            </a:r>
-            <a:endParaRPr lang="en-US" sz="850" dirty="0"/>
-          </a:p>
-        </p:txBody>
-      </p:sp>
-      <p:sp>
-        <p:nvSpPr>
-          <p:cNvPr id="35" name="Shape 33"/>
-          <p:cNvSpPr/>
-          <p:nvPr/>
-        </p:nvSpPr>
-        <p:spPr>
-          <a:xfrm>
-            <a:off x="4023360" y="2880360"/>
-            <a:ext cx="2468880" cy="1078992"/>
-          </a:xfrm>
-          <a:prstGeom prst="rect">
-            <a:avLst/>
-          </a:prstGeom>
-          <a:solidFill>
-            <a:srgbClr val="FFFFFF"/>
-          </a:solidFill>
-          <a:ln w="15875">
-            <a:solidFill>
-              <a:srgbClr val="3A3F4B"/>
-            </a:solidFill>
-            <a:prstDash val="solid"/>
-          </a:ln>
-        </p:spPr>
-      </p:sp>
-      <p:sp>
-        <p:nvSpPr>
-          <p:cNvPr id="36" name="Shape 34"/>
-          <p:cNvSpPr/>
-          <p:nvPr/>
-        </p:nvSpPr>
-        <p:spPr>
-          <a:xfrm>
-            <a:off x="4023360" y="2880360"/>
-            <a:ext cx="2468880" cy="292608"/>
-          </a:xfrm>
-          <a:prstGeom prst="rect">
-            <a:avLst/>
-          </a:prstGeom>
-          <a:solidFill>
-            <a:srgbClr val="3A3F4B"/>
-          </a:solidFill>
-          <a:ln w="15875">
-            <a:solidFill>
-              <a:srgbClr val="3A3F4B"/>
-            </a:solidFill>
-            <a:prstDash val="solid"/>
-          </a:ln>
-        </p:spPr>
-      </p:sp>
-      <p:sp>
-        <p:nvSpPr>
-          <p:cNvPr id="37" name="Text 35"/>
-          <p:cNvSpPr txBox="1"/>
-          <p:nvPr/>
-        </p:nvSpPr>
-        <p:spPr>
-          <a:xfrm>
-            <a:off x="4023360" y="2880360"/>
-            <a:ext cx="2468880" cy="292608"/>
-          </a:xfrm>
-          <a:prstGeom prst="rect">
-            <a:avLst/>
-          </a:prstGeom>
-          <a:noFill/>
-          <a:ln/>
-        </p:spPr>
-        <p:txBody>
-          <a:bodyPr wrap="square" lIns="0" tIns="0" rIns="0" bIns="0" rtlCol="0" anchor="ctr"/>
-          <a:lstStyle/>
-          <a:p>
-            <a:pPr algn="ctr" indent="0" marL="0">
-              <a:buNone/>
-            </a:pPr>
-            <a:r>
-              <a:rPr lang="en-US" sz="1100" b="1" dirty="0">
-                <a:solidFill>
-                  <a:srgbClr val="FFFFFF"/>
-                </a:solidFill>
-                <a:latin typeface="Calibri" pitchFamily="34" charset="0"/>
-                <a:ea typeface="Calibri" pitchFamily="34" charset="-122"/>
-                <a:cs typeface="Calibri" pitchFamily="34" charset="-120"/>
-              </a:rPr>
-              <a:t>ProxyReportes</a:t>
-            </a:r>
-            <a:endParaRPr lang="en-US" sz="1400" dirty="0"/>
-          </a:p>
-        </p:txBody>
-      </p:sp>
-      <p:sp>
-        <p:nvSpPr>
-          <p:cNvPr id="38" name="Text 36"/>
-          <p:cNvSpPr txBox="1"/>
-          <p:nvPr/>
-        </p:nvSpPr>
-        <p:spPr>
-          <a:xfrm>
-            <a:off x="4096512" y="3218688"/>
-            <a:ext cx="2359152" cy="740664"/>
-          </a:xfrm>
-          <a:prstGeom prst="rect">
-            <a:avLst/>
-          </a:prstGeom>
-          <a:noFill/>
-          <a:ln/>
-        </p:spPr>
-        <p:txBody>
-          <a:bodyPr wrap="square" lIns="0" tIns="0" rIns="0" bIns="0" rtlCol="0" anchor="t"/>
-          <a:lstStyle/>
-          <a:p>
-            <a:pPr indent="0" marL="0">
-              <a:buNone/>
-            </a:pPr>
-            <a:r>
-              <a:rPr lang="en-US" sz="850" dirty="0">
-                <a:solidFill>
-                  <a:srgbClr val="1B2333"/>
-                </a:solidFill>
-                <a:latin typeface="Courier New" pitchFamily="34" charset="0"/>
-                <a:ea typeface="Courier New" pitchFamily="34" charset="-122"/>
-                <a:cs typeface="Courier New" pitchFamily="34" charset="-120"/>
-              </a:rPr>
-              <a:t>- usuario, rol: String</a:t>
-            </a:r>
-            <a:endParaRPr lang="en-US" sz="850" dirty="0"/>
-          </a:p>
-          <a:p>
-            <a:pPr indent="0" marL="0">
-              <a:buNone/>
-            </a:pPr>
-            <a:r>
-              <a:rPr lang="en-US" sz="850" dirty="0">
-                <a:solidFill>
-                  <a:srgbClr val="1B2333"/>
-                </a:solidFill>
-                <a:latin typeface="Courier New" pitchFamily="34" charset="0"/>
-                <a:ea typeface="Courier New" pitchFamily="34" charset="-122"/>
-                <a:cs typeface="Courier New" pitchFamily="34" charset="-120"/>
-              </a:rPr>
-              <a:t>- real: ...Real</a:t>
-            </a:r>
-            <a:endParaRPr lang="en-US" sz="850" dirty="0"/>
-          </a:p>
-          <a:p>
-            <a:pPr indent="0" marL="0">
-              <a:buNone/>
-            </a:pPr>
-            <a:r>
-              <a:rPr lang="en-US" sz="850" dirty="0">
-                <a:solidFill>
-                  <a:srgbClr val="1B2333"/>
-                </a:solidFill>
-                <a:latin typeface="Courier New" pitchFamily="34" charset="0"/>
-                <a:ea typeface="Courier New" pitchFamily="34" charset="-122"/>
-                <a:cs typeface="Courier New" pitchFamily="34" charset="-120"/>
-              </a:rPr>
-              <a:t>- cache: Map</a:t>
-            </a:r>
-            <a:endParaRPr lang="en-US" sz="850" dirty="0"/>
-          </a:p>
-          <a:p>
-            <a:pPr indent="0" marL="0">
-              <a:buNone/>
-            </a:pPr>
-            <a:r>
-              <a:rPr lang="en-US" sz="850" dirty="0">
-                <a:solidFill>
-                  <a:srgbClr val="1B2333"/>
-                </a:solidFill>
-                <a:latin typeface="Courier New" pitchFamily="34" charset="0"/>
-                <a:ea typeface="Courier New" pitchFamily="34" charset="-122"/>
-                <a:cs typeface="Courier New" pitchFamily="34" charset="-120"/>
-              </a:rPr>
-              <a:t>+ obtenerReporte(id)</a:t>
-            </a:r>
-            <a:endParaRPr lang="en-US" sz="850" dirty="0"/>
-          </a:p>
-        </p:txBody>
-      </p:sp>
-      <p:sp>
-        <p:nvSpPr>
-          <p:cNvPr id="39" name="Shape 37"/>
-          <p:cNvSpPr/>
-          <p:nvPr/>
-        </p:nvSpPr>
-        <p:spPr>
-          <a:xfrm>
-            <a:off x="2194560" y="1325880"/>
-            <a:ext cx="822960" cy="137160"/>
-          </a:xfrm>
-          <a:prstGeom prst="line">
-            <a:avLst/>
-          </a:prstGeom>
-          <a:noFill/>
-          <a:ln w="15875">
-            <a:solidFill>
-              <a:srgbClr val="3A3F4B"/>
-            </a:solidFill>
-            <a:prstDash val="solid"/>
-            <a:tailEnd type="arrow"/>
-          </a:ln>
-        </p:spPr>
-      </p:sp>
-      <p:sp>
-        <p:nvSpPr>
-          <p:cNvPr id="40" name="Shape 38"/>
-          <p:cNvSpPr/>
-          <p:nvPr/>
-        </p:nvSpPr>
-        <p:spPr>
-          <a:xfrm flipV="1">
-            <a:off x="1828800" y="1682496"/>
-            <a:ext cx="1737360" cy="1380744"/>
-          </a:xfrm>
-          <a:prstGeom prst="line">
-            <a:avLst/>
-          </a:prstGeom>
-          <a:noFill/>
-          <a:ln w="15875">
-            <a:solidFill>
-              <a:srgbClr val="3A3F4B"/>
-            </a:solidFill>
-            <a:prstDash val="dash"/>
-            <a:tailEnd type="triangle"/>
-          </a:ln>
-        </p:spPr>
-      </p:sp>
-      <p:sp>
-        <p:nvSpPr>
-          <p:cNvPr id="41" name="Shape 39"/>
-          <p:cNvSpPr/>
-          <p:nvPr/>
-        </p:nvSpPr>
-        <p:spPr>
-          <a:xfrm flipV="1">
-            <a:off x="5257800" y="1682496"/>
-            <a:ext cx="502920" cy="1197864"/>
-          </a:xfrm>
-          <a:prstGeom prst="line">
-            <a:avLst/>
-          </a:prstGeom>
-          <a:noFill/>
-          <a:ln w="15875">
-            <a:solidFill>
-              <a:srgbClr val="3A3F4B"/>
-            </a:solidFill>
-            <a:prstDash val="dash"/>
-            <a:tailEnd type="triangle"/>
-          </a:ln>
-        </p:spPr>
-      </p:sp>
-      <p:sp>
-        <p:nvSpPr>
-          <p:cNvPr id="42" name="Shape 40"/>
-          <p:cNvSpPr/>
-          <p:nvPr/>
-        </p:nvSpPr>
-        <p:spPr>
-          <a:xfrm flipH="1">
-            <a:off x="3200400" y="3657600"/>
-            <a:ext cx="822960" cy="182880"/>
-          </a:xfrm>
-          <a:prstGeom prst="line">
-            <a:avLst/>
-          </a:prstGeom>
-          <a:noFill/>
-          <a:ln w="15875">
-            <a:solidFill>
-              <a:srgbClr val="3A3F4B"/>
-            </a:solidFill>
-            <a:prstDash val="solid"/>
-            <a:tailEnd type="arrow"/>
-          </a:ln>
-        </p:spPr>
-      </p:sp>
-      <p:sp>
-        <p:nvSpPr>
-          <p:cNvPr id="43" name="Text 41"/>
-          <p:cNvSpPr txBox="1"/>
-          <p:nvPr/>
-        </p:nvSpPr>
-        <p:spPr>
-          <a:xfrm>
-            <a:off x="3246120" y="3364992"/>
-            <a:ext cx="777240" cy="182880"/>
-          </a:xfrm>
-          <a:prstGeom prst="rect">
-            <a:avLst/>
-          </a:prstGeom>
-          <a:noFill/>
-          <a:ln/>
-        </p:spPr>
-        <p:txBody>
-          <a:bodyPr wrap="square" lIns="0" tIns="0" rIns="0" bIns="0" rtlCol="0" anchor="t"/>
-          <a:lstStyle/>
-          <a:p>
-            <a:pPr indent="0" marL="0">
-              <a:buNone/>
-            </a:pPr>
-            <a:r>
-              <a:rPr lang="en-US" sz="850" i="1" dirty="0">
-                <a:solidFill>
-                  <a:srgbClr val="5B6577"/>
-                </a:solidFill>
-                <a:latin typeface="Calibri" pitchFamily="34" charset="0"/>
-                <a:ea typeface="Calibri" pitchFamily="34" charset="-122"/>
-                <a:cs typeface="Calibri" pitchFamily="34" charset="-120"/>
-              </a:rPr>
-              <a:t>delega en</a:t>
-            </a:r>
-            <a:endParaRPr lang="en-US" sz="850" dirty="0"/>
-          </a:p>
-        </p:txBody>
-      </p:sp>
-      <p:sp>
-        <p:nvSpPr>
           <p:cNvPr id="44" name="Shape 42"/>
           <p:cNvSpPr/>
           <p:nvPr/>
@@ -29741,6 +27155,30 @@
           </a:p>
         </p:txBody>
       </p:sp>
+      <p:pic>
+        <p:nvPicPr>
+          <p:cNvPr id="56" name="Picture 55" descr="clases.png"/>
+          <p:cNvPicPr>
+            <a:picLocks noChangeAspect="1"/>
+          </p:cNvPicPr>
+          <p:nvPr/>
+        </p:nvPicPr>
+        <p:blipFill>
+          <a:blip r:embed="rId3"/>
+          <a:stretch>
+            <a:fillRect/>
+          </a:stretch>
+        </p:blipFill>
+        <p:spPr>
+          <a:xfrm>
+            <a:off x="1742655" y="960120"/>
+            <a:ext cx="3738449" cy="3593592"/>
+          </a:xfrm>
+          <a:prstGeom prst="rect">
+            <a:avLst/>
+          </a:prstGeom>
+        </p:spPr>
+      </p:pic>
     </p:spTree>
   </p:cSld>
   <p:clrMapOvr>
@@ -44576,1293 +42014,6 @@
       </p:sp>
       <p:sp>
         <p:nvSpPr>
-          <p:cNvPr id="23" name="Shape 21"/>
-          <p:cNvSpPr/>
-          <p:nvPr/>
-        </p:nvSpPr>
-        <p:spPr>
-          <a:xfrm>
-            <a:off x="457200" y="960120"/>
-            <a:ext cx="1737360" cy="722376"/>
-          </a:xfrm>
-          <a:prstGeom prst="rect">
-            <a:avLst/>
-          </a:prstGeom>
-          <a:solidFill>
-            <a:srgbClr val="FFFFFF"/>
-          </a:solidFill>
-          <a:ln w="15875">
-            <a:solidFill>
-              <a:srgbClr val="3A3F4B"/>
-            </a:solidFill>
-            <a:prstDash val="solid"/>
-          </a:ln>
-        </p:spPr>
-      </p:sp>
-      <p:sp>
-        <p:nvSpPr>
-          <p:cNvPr id="24" name="Shape 22"/>
-          <p:cNvSpPr/>
-          <p:nvPr/>
-        </p:nvSpPr>
-        <p:spPr>
-          <a:xfrm>
-            <a:off x="457200" y="960120"/>
-            <a:ext cx="1737360" cy="457200"/>
-          </a:xfrm>
-          <a:prstGeom prst="rect">
-            <a:avLst/>
-          </a:prstGeom>
-          <a:solidFill>
-            <a:srgbClr val="5BB4F0"/>
-          </a:solidFill>
-          <a:ln w="15875">
-            <a:solidFill>
-              <a:srgbClr val="3A3F4B"/>
-            </a:solidFill>
-            <a:prstDash val="solid"/>
-          </a:ln>
-        </p:spPr>
-      </p:sp>
-      <p:sp>
-        <p:nvSpPr>
-          <p:cNvPr id="25" name="Text 23"/>
-          <p:cNvSpPr txBox="1"/>
-          <p:nvPr/>
-        </p:nvSpPr>
-        <p:spPr>
-          <a:xfrm>
-            <a:off x="457200" y="960120"/>
-            <a:ext cx="1737360" cy="457200"/>
-          </a:xfrm>
-          <a:prstGeom prst="rect">
-            <a:avLst/>
-          </a:prstGeom>
-          <a:noFill/>
-          <a:ln/>
-        </p:spPr>
-        <p:txBody>
-          <a:bodyPr wrap="square" lIns="0" tIns="0" rIns="0" bIns="0" rtlCol="0" anchor="ctr"/>
-          <a:lstStyle/>
-          <a:p>
-            <a:pPr algn="ctr" indent="0" marL="0">
-              <a:buNone/>
-            </a:pPr>
-            <a:r>
-              <a:rPr lang="en-US" sz="800" i="1" dirty="0">
-                <a:solidFill>
-                  <a:srgbClr val="3A3F4B"/>
-                </a:solidFill>
-                <a:latin typeface="Calibri" pitchFamily="34" charset="0"/>
-                <a:ea typeface="Calibri" pitchFamily="34" charset="-122"/>
-                <a:cs typeface="Calibri" pitchFamily="34" charset="-120"/>
-              </a:rPr>
-              <a:t>«control»</a:t>
-            </a:r>
-            <a:endParaRPr lang="en-US" sz="1400" dirty="0"/>
-          </a:p>
-          <a:p>
-            <a:pPr algn="ctr" indent="0" marL="0">
-              <a:buNone/>
-            </a:pPr>
-            <a:r>
-              <a:rPr lang="en-US" sz="1100" b="1" dirty="0">
-                <a:solidFill>
-                  <a:srgbClr val="3A3F4B"/>
-                </a:solidFill>
-                <a:latin typeface="Calibri" pitchFamily="34" charset="0"/>
-                <a:ea typeface="Calibri" pitchFamily="34" charset="-122"/>
-                <a:cs typeface="Calibri" pitchFamily="34" charset="-120"/>
-              </a:rPr>
-              <a:t>Main</a:t>
-            </a:r>
-            <a:endParaRPr lang="en-US" sz="1400" dirty="0"/>
-          </a:p>
-        </p:txBody>
-      </p:sp>
-      <p:sp>
-        <p:nvSpPr>
-          <p:cNvPr id="26" name="Text 24"/>
-          <p:cNvSpPr txBox="1"/>
-          <p:nvPr/>
-        </p:nvSpPr>
-        <p:spPr>
-          <a:xfrm>
-            <a:off x="530352" y="1463040"/>
-            <a:ext cx="1627632" cy="219456"/>
-          </a:xfrm>
-          <a:prstGeom prst="rect">
-            <a:avLst/>
-          </a:prstGeom>
-          <a:noFill/>
-          <a:ln/>
-        </p:spPr>
-        <p:txBody>
-          <a:bodyPr wrap="square" lIns="0" tIns="0" rIns="0" bIns="0" rtlCol="0" anchor="t"/>
-          <a:lstStyle/>
-          <a:p>
-            <a:pPr indent="0" marL="0">
-              <a:buNone/>
-            </a:pPr>
-            <a:r>
-              <a:rPr lang="en-US" sz="850" dirty="0">
-                <a:solidFill>
-                  <a:srgbClr val="1B2333"/>
-                </a:solidFill>
-                <a:latin typeface="Courier New" pitchFamily="34" charset="0"/>
-                <a:ea typeface="Courier New" pitchFamily="34" charset="-122"/>
-                <a:cs typeface="Courier New" pitchFamily="34" charset="-120"/>
-              </a:rPr>
-              <a:t>(cliente)</a:t>
-            </a:r>
-            <a:endParaRPr lang="en-US" sz="850" dirty="0"/>
-          </a:p>
-        </p:txBody>
-      </p:sp>
-      <p:sp>
-        <p:nvSpPr>
-          <p:cNvPr id="27" name="Shape 25"/>
-          <p:cNvSpPr/>
-          <p:nvPr/>
-        </p:nvSpPr>
-        <p:spPr>
-          <a:xfrm>
-            <a:off x="3154680" y="960120"/>
-            <a:ext cx="2468880" cy="896112"/>
-          </a:xfrm>
-          <a:prstGeom prst="rect">
-            <a:avLst/>
-          </a:prstGeom>
-          <a:solidFill>
-            <a:srgbClr val="FFFFFF"/>
-          </a:solidFill>
-          <a:ln w="15875">
-            <a:solidFill>
-              <a:srgbClr val="3A3F4B"/>
-            </a:solidFill>
-            <a:prstDash val="solid"/>
-          </a:ln>
-        </p:spPr>
-      </p:sp>
-      <p:sp>
-        <p:nvSpPr>
-          <p:cNvPr id="28" name="Shape 26"/>
-          <p:cNvSpPr/>
-          <p:nvPr/>
-        </p:nvSpPr>
-        <p:spPr>
-          <a:xfrm>
-            <a:off x="3154680" y="960120"/>
-            <a:ext cx="2468880" cy="457200"/>
-          </a:xfrm>
-          <a:prstGeom prst="rect">
-            <a:avLst/>
-          </a:prstGeom>
-          <a:solidFill>
-            <a:srgbClr val="3A3F4B"/>
-          </a:solidFill>
-          <a:ln w="15875">
-            <a:solidFill>
-              <a:srgbClr val="3A3F4B"/>
-            </a:solidFill>
-            <a:prstDash val="solid"/>
-          </a:ln>
-        </p:spPr>
-      </p:sp>
-      <p:sp>
-        <p:nvSpPr>
-          <p:cNvPr id="29" name="Text 27"/>
-          <p:cNvSpPr txBox="1"/>
-          <p:nvPr/>
-        </p:nvSpPr>
-        <p:spPr>
-          <a:xfrm>
-            <a:off x="3154680" y="960120"/>
-            <a:ext cx="2468880" cy="457200"/>
-          </a:xfrm>
-          <a:prstGeom prst="rect">
-            <a:avLst/>
-          </a:prstGeom>
-          <a:noFill/>
-          <a:ln/>
-        </p:spPr>
-        <p:txBody>
-          <a:bodyPr wrap="square" lIns="0" tIns="0" rIns="0" bIns="0" rtlCol="0" anchor="ctr"/>
-          <a:lstStyle/>
-          <a:p>
-            <a:pPr algn="ctr" indent="0" marL="0">
-              <a:buNone/>
-            </a:pPr>
-            <a:r>
-              <a:rPr lang="en-US" sz="800" i="1" dirty="0">
-                <a:solidFill>
-                  <a:srgbClr val="CADCFC"/>
-                </a:solidFill>
-                <a:latin typeface="Calibri" pitchFamily="34" charset="0"/>
-                <a:ea typeface="Calibri" pitchFamily="34" charset="-122"/>
-                <a:cs typeface="Calibri" pitchFamily="34" charset="-120"/>
-              </a:rPr>
-              <a:t>«interface»</a:t>
-            </a:r>
-            <a:endParaRPr lang="en-US" sz="1400" dirty="0"/>
-          </a:p>
-          <a:p>
-            <a:pPr algn="ctr" indent="0" marL="0">
-              <a:buNone/>
-            </a:pPr>
-            <a:r>
-              <a:rPr lang="en-US" sz="1100" b="1" dirty="0">
-                <a:solidFill>
-                  <a:srgbClr val="FFFFFF"/>
-                </a:solidFill>
-                <a:latin typeface="Calibri" pitchFamily="34" charset="0"/>
-                <a:ea typeface="Calibri" pitchFamily="34" charset="-122"/>
-                <a:cs typeface="Calibri" pitchFamily="34" charset="-120"/>
-              </a:rPr>
-              <a:t>Tiquete</a:t>
-            </a:r>
-            <a:endParaRPr lang="en-US" sz="1400" dirty="0"/>
-          </a:p>
-        </p:txBody>
-      </p:sp>
-      <p:sp>
-        <p:nvSpPr>
-          <p:cNvPr id="30" name="Text 28"/>
-          <p:cNvSpPr txBox="1"/>
-          <p:nvPr/>
-        </p:nvSpPr>
-        <p:spPr>
-          <a:xfrm>
-            <a:off x="3227832" y="1463040"/>
-            <a:ext cx="2359152" cy="393192"/>
-          </a:xfrm>
-          <a:prstGeom prst="rect">
-            <a:avLst/>
-          </a:prstGeom>
-          <a:noFill/>
-          <a:ln/>
-        </p:spPr>
-        <p:txBody>
-          <a:bodyPr wrap="square" lIns="0" tIns="0" rIns="0" bIns="0" rtlCol="0" anchor="t"/>
-          <a:lstStyle/>
-          <a:p>
-            <a:pPr indent="0" marL="0">
-              <a:buNone/>
-            </a:pPr>
-            <a:r>
-              <a:rPr lang="en-US" sz="850" dirty="0">
-                <a:solidFill>
-                  <a:srgbClr val="1B2333"/>
-                </a:solidFill>
-                <a:latin typeface="Courier New" pitchFamily="34" charset="0"/>
-                <a:ea typeface="Courier New" pitchFamily="34" charset="-122"/>
-                <a:cs typeface="Courier New" pitchFamily="34" charset="-120"/>
-              </a:rPr>
-              <a:t>+ descripcion(): String</a:t>
-            </a:r>
-            <a:endParaRPr lang="en-US" sz="850" dirty="0"/>
-          </a:p>
-          <a:p>
-            <a:pPr indent="0" marL="0">
-              <a:buNone/>
-            </a:pPr>
-            <a:r>
-              <a:rPr lang="en-US" sz="850" dirty="0">
-                <a:solidFill>
-                  <a:srgbClr val="1B2333"/>
-                </a:solidFill>
-                <a:latin typeface="Courier New" pitchFamily="34" charset="0"/>
-                <a:ea typeface="Courier New" pitchFamily="34" charset="-122"/>
-                <a:cs typeface="Courier New" pitchFamily="34" charset="-120"/>
-              </a:rPr>
-              <a:t>+ costo(): double</a:t>
-            </a:r>
-            <a:endParaRPr lang="en-US" sz="850" dirty="0"/>
-          </a:p>
-        </p:txBody>
-      </p:sp>
-      <p:sp>
-        <p:nvSpPr>
-          <p:cNvPr id="31" name="Shape 29"/>
-          <p:cNvSpPr/>
-          <p:nvPr/>
-        </p:nvSpPr>
-        <p:spPr>
-          <a:xfrm>
-            <a:off x="457200" y="2377440"/>
-            <a:ext cx="2377440" cy="1078992"/>
-          </a:xfrm>
-          <a:prstGeom prst="rect">
-            <a:avLst/>
-          </a:prstGeom>
-          <a:solidFill>
-            <a:srgbClr val="FFFFFF"/>
-          </a:solidFill>
-          <a:ln w="15875">
-            <a:solidFill>
-              <a:srgbClr val="3A3F4B"/>
-            </a:solidFill>
-            <a:prstDash val="solid"/>
-          </a:ln>
-        </p:spPr>
-      </p:sp>
-      <p:sp>
-        <p:nvSpPr>
-          <p:cNvPr id="32" name="Shape 30"/>
-          <p:cNvSpPr/>
-          <p:nvPr/>
-        </p:nvSpPr>
-        <p:spPr>
-          <a:xfrm>
-            <a:off x="457200" y="2377440"/>
-            <a:ext cx="2377440" cy="292608"/>
-          </a:xfrm>
-          <a:prstGeom prst="rect">
-            <a:avLst/>
-          </a:prstGeom>
-          <a:solidFill>
-            <a:srgbClr val="3A3F4B"/>
-          </a:solidFill>
-          <a:ln w="15875">
-            <a:solidFill>
-              <a:srgbClr val="3A3F4B"/>
-            </a:solidFill>
-            <a:prstDash val="solid"/>
-          </a:ln>
-        </p:spPr>
-      </p:sp>
-      <p:sp>
-        <p:nvSpPr>
-          <p:cNvPr id="33" name="Text 31"/>
-          <p:cNvSpPr txBox="1"/>
-          <p:nvPr/>
-        </p:nvSpPr>
-        <p:spPr>
-          <a:xfrm>
-            <a:off x="457200" y="2377440"/>
-            <a:ext cx="2377440" cy="292608"/>
-          </a:xfrm>
-          <a:prstGeom prst="rect">
-            <a:avLst/>
-          </a:prstGeom>
-          <a:noFill/>
-          <a:ln/>
-        </p:spPr>
-        <p:txBody>
-          <a:bodyPr wrap="square" lIns="0" tIns="0" rIns="0" bIns="0" rtlCol="0" anchor="ctr"/>
-          <a:lstStyle/>
-          <a:p>
-            <a:pPr algn="ctr" indent="0" marL="0">
-              <a:buNone/>
-            </a:pPr>
-            <a:r>
-              <a:rPr lang="en-US" sz="1100" b="1" dirty="0">
-                <a:solidFill>
-                  <a:srgbClr val="FFFFFF"/>
-                </a:solidFill>
-                <a:latin typeface="Calibri" pitchFamily="34" charset="0"/>
-                <a:ea typeface="Calibri" pitchFamily="34" charset="-122"/>
-                <a:cs typeface="Calibri" pitchFamily="34" charset="-120"/>
-              </a:rPr>
-              <a:t>TiqueteBasico</a:t>
-            </a:r>
-            <a:endParaRPr lang="en-US" sz="1400" dirty="0"/>
-          </a:p>
-        </p:txBody>
-      </p:sp>
-      <p:sp>
-        <p:nvSpPr>
-          <p:cNvPr id="34" name="Text 32"/>
-          <p:cNvSpPr txBox="1"/>
-          <p:nvPr/>
-        </p:nvSpPr>
-        <p:spPr>
-          <a:xfrm>
-            <a:off x="530352" y="2715768"/>
-            <a:ext cx="2267712" cy="740664"/>
-          </a:xfrm>
-          <a:prstGeom prst="rect">
-            <a:avLst/>
-          </a:prstGeom>
-          <a:noFill/>
-          <a:ln/>
-        </p:spPr>
-        <p:txBody>
-          <a:bodyPr wrap="square" lIns="0" tIns="0" rIns="0" bIns="0" rtlCol="0" anchor="t"/>
-          <a:lstStyle/>
-          <a:p>
-            <a:pPr indent="0" marL="0">
-              <a:buNone/>
-            </a:pPr>
-            <a:r>
-              <a:rPr lang="en-US" sz="850" dirty="0">
-                <a:solidFill>
-                  <a:srgbClr val="1B2333"/>
-                </a:solidFill>
-                <a:latin typeface="Courier New" pitchFamily="34" charset="0"/>
-                <a:ea typeface="Courier New" pitchFamily="34" charset="-122"/>
-                <a:cs typeface="Courier New" pitchFamily="34" charset="-120"/>
-              </a:rPr>
-              <a:t>- ruta: String</a:t>
-            </a:r>
-            <a:endParaRPr lang="en-US" sz="850" dirty="0"/>
-          </a:p>
-          <a:p>
-            <a:pPr indent="0" marL="0">
-              <a:buNone/>
-            </a:pPr>
-            <a:r>
-              <a:rPr lang="en-US" sz="850" dirty="0">
-                <a:solidFill>
-                  <a:srgbClr val="1B2333"/>
-                </a:solidFill>
-                <a:latin typeface="Courier New" pitchFamily="34" charset="0"/>
-                <a:ea typeface="Courier New" pitchFamily="34" charset="-122"/>
-                <a:cs typeface="Courier New" pitchFamily="34" charset="-120"/>
-              </a:rPr>
-              <a:t>- tarifa: double</a:t>
-            </a:r>
-            <a:endParaRPr lang="en-US" sz="850" dirty="0"/>
-          </a:p>
-          <a:p>
-            <a:pPr indent="0" marL="0">
-              <a:buNone/>
-            </a:pPr>
-            <a:r>
-              <a:rPr lang="en-US" sz="850" dirty="0">
-                <a:solidFill>
-                  <a:srgbClr val="1B2333"/>
-                </a:solidFill>
-                <a:latin typeface="Courier New" pitchFamily="34" charset="0"/>
-                <a:ea typeface="Courier New" pitchFamily="34" charset="-122"/>
-                <a:cs typeface="Courier New" pitchFamily="34" charset="-120"/>
-              </a:rPr>
-              <a:t>+ descripcion()</a:t>
-            </a:r>
-            <a:endParaRPr lang="en-US" sz="850" dirty="0"/>
-          </a:p>
-          <a:p>
-            <a:pPr indent="0" marL="0">
-              <a:buNone/>
-            </a:pPr>
-            <a:r>
-              <a:rPr lang="en-US" sz="850" dirty="0">
-                <a:solidFill>
-                  <a:srgbClr val="1B2333"/>
-                </a:solidFill>
-                <a:latin typeface="Courier New" pitchFamily="34" charset="0"/>
-                <a:ea typeface="Courier New" pitchFamily="34" charset="-122"/>
-                <a:cs typeface="Courier New" pitchFamily="34" charset="-120"/>
-              </a:rPr>
-              <a:t>+ costo()</a:t>
-            </a:r>
-            <a:endParaRPr lang="en-US" sz="850" dirty="0"/>
-          </a:p>
-        </p:txBody>
-      </p:sp>
-      <p:sp>
-        <p:nvSpPr>
-          <p:cNvPr id="35" name="Shape 33"/>
-          <p:cNvSpPr/>
-          <p:nvPr/>
-        </p:nvSpPr>
-        <p:spPr>
-          <a:xfrm>
-            <a:off x="3154680" y="2377440"/>
-            <a:ext cx="2468880" cy="905256"/>
-          </a:xfrm>
-          <a:prstGeom prst="rect">
-            <a:avLst/>
-          </a:prstGeom>
-          <a:solidFill>
-            <a:srgbClr val="FFFFFF"/>
-          </a:solidFill>
-          <a:ln w="15875">
-            <a:solidFill>
-              <a:srgbClr val="3A3F4B"/>
-            </a:solidFill>
-            <a:prstDash val="solid"/>
-          </a:ln>
-        </p:spPr>
-      </p:sp>
-      <p:sp>
-        <p:nvSpPr>
-          <p:cNvPr id="36" name="Shape 34"/>
-          <p:cNvSpPr/>
-          <p:nvPr/>
-        </p:nvSpPr>
-        <p:spPr>
-          <a:xfrm>
-            <a:off x="3154680" y="2377440"/>
-            <a:ext cx="2468880" cy="292608"/>
-          </a:xfrm>
-          <a:prstGeom prst="rect">
-            <a:avLst/>
-          </a:prstGeom>
-          <a:solidFill>
-            <a:srgbClr val="3A3F4B"/>
-          </a:solidFill>
-          <a:ln w="15875">
-            <a:solidFill>
-              <a:srgbClr val="3A3F4B"/>
-            </a:solidFill>
-            <a:prstDash val="solid"/>
-          </a:ln>
-        </p:spPr>
-      </p:sp>
-      <p:sp>
-        <p:nvSpPr>
-          <p:cNvPr id="37" name="Text 35"/>
-          <p:cNvSpPr txBox="1"/>
-          <p:nvPr/>
-        </p:nvSpPr>
-        <p:spPr>
-          <a:xfrm>
-            <a:off x="3154680" y="2377440"/>
-            <a:ext cx="2468880" cy="292608"/>
-          </a:xfrm>
-          <a:prstGeom prst="rect">
-            <a:avLst/>
-          </a:prstGeom>
-          <a:noFill/>
-          <a:ln/>
-        </p:spPr>
-        <p:txBody>
-          <a:bodyPr wrap="square" lIns="0" tIns="0" rIns="0" bIns="0" rtlCol="0" anchor="ctr"/>
-          <a:lstStyle/>
-          <a:p>
-            <a:pPr algn="ctr" indent="0" marL="0">
-              <a:buNone/>
-            </a:pPr>
-            <a:r>
-              <a:rPr lang="en-US" sz="1100" b="1" i="1" dirty="0">
-                <a:solidFill>
-                  <a:srgbClr val="FFFFFF"/>
-                </a:solidFill>
-                <a:latin typeface="Calibri" pitchFamily="34" charset="0"/>
-                <a:ea typeface="Calibri" pitchFamily="34" charset="-122"/>
-                <a:cs typeface="Calibri" pitchFamily="34" charset="-120"/>
-              </a:rPr>
-              <a:t>TiqueteDecorator</a:t>
-            </a:r>
-            <a:endParaRPr lang="en-US" sz="1400" dirty="0"/>
-          </a:p>
-        </p:txBody>
-      </p:sp>
-      <p:sp>
-        <p:nvSpPr>
-          <p:cNvPr id="38" name="Text 36"/>
-          <p:cNvSpPr txBox="1"/>
-          <p:nvPr/>
-        </p:nvSpPr>
-        <p:spPr>
-          <a:xfrm>
-            <a:off x="3227832" y="2715768"/>
-            <a:ext cx="2359152" cy="566928"/>
-          </a:xfrm>
-          <a:prstGeom prst="rect">
-            <a:avLst/>
-          </a:prstGeom>
-          <a:noFill/>
-          <a:ln/>
-        </p:spPr>
-        <p:txBody>
-          <a:bodyPr wrap="square" lIns="0" tIns="0" rIns="0" bIns="0" rtlCol="0" anchor="t"/>
-          <a:lstStyle/>
-          <a:p>
-            <a:pPr indent="0" marL="0">
-              <a:buNone/>
-            </a:pPr>
-            <a:r>
-              <a:rPr lang="en-US" sz="850" dirty="0">
-                <a:solidFill>
-                  <a:srgbClr val="1B2333"/>
-                </a:solidFill>
-                <a:latin typeface="Courier New" pitchFamily="34" charset="0"/>
-                <a:ea typeface="Courier New" pitchFamily="34" charset="-122"/>
-                <a:cs typeface="Courier New" pitchFamily="34" charset="-120"/>
-              </a:rPr>
-              <a:t># envuelto: Tiquete</a:t>
-            </a:r>
-            <a:endParaRPr lang="en-US" sz="850" dirty="0"/>
-          </a:p>
-          <a:p>
-            <a:pPr indent="0" marL="0">
-              <a:buNone/>
-            </a:pPr>
-            <a:r>
-              <a:rPr lang="en-US" sz="850" dirty="0">
-                <a:solidFill>
-                  <a:srgbClr val="1B2333"/>
-                </a:solidFill>
-                <a:latin typeface="Courier New" pitchFamily="34" charset="0"/>
-                <a:ea typeface="Courier New" pitchFamily="34" charset="-122"/>
-                <a:cs typeface="Courier New" pitchFamily="34" charset="-120"/>
-              </a:rPr>
-              <a:t>+ descripcion()</a:t>
-            </a:r>
-            <a:endParaRPr lang="en-US" sz="850" dirty="0"/>
-          </a:p>
-          <a:p>
-            <a:pPr indent="0" marL="0">
-              <a:buNone/>
-            </a:pPr>
-            <a:r>
-              <a:rPr lang="en-US" sz="850" dirty="0">
-                <a:solidFill>
-                  <a:srgbClr val="1B2333"/>
-                </a:solidFill>
-                <a:latin typeface="Courier New" pitchFamily="34" charset="0"/>
-                <a:ea typeface="Courier New" pitchFamily="34" charset="-122"/>
-                <a:cs typeface="Courier New" pitchFamily="34" charset="-120"/>
-              </a:rPr>
-              <a:t>+ costo()</a:t>
-            </a:r>
-            <a:endParaRPr lang="en-US" sz="850" dirty="0"/>
-          </a:p>
-        </p:txBody>
-      </p:sp>
-      <p:sp>
-        <p:nvSpPr>
-          <p:cNvPr id="39" name="Shape 37"/>
-          <p:cNvSpPr/>
-          <p:nvPr/>
-        </p:nvSpPr>
-        <p:spPr>
-          <a:xfrm>
-            <a:off x="1325880" y="3657600"/>
-            <a:ext cx="1691640" cy="557784"/>
-          </a:xfrm>
-          <a:prstGeom prst="rect">
-            <a:avLst/>
-          </a:prstGeom>
-          <a:solidFill>
-            <a:srgbClr val="FFFFFF"/>
-          </a:solidFill>
-          <a:ln w="15875">
-            <a:solidFill>
-              <a:srgbClr val="3A3F4B"/>
-            </a:solidFill>
-            <a:prstDash val="solid"/>
-          </a:ln>
-        </p:spPr>
-      </p:sp>
-      <p:sp>
-        <p:nvSpPr>
-          <p:cNvPr id="40" name="Shape 38"/>
-          <p:cNvSpPr/>
-          <p:nvPr/>
-        </p:nvSpPr>
-        <p:spPr>
-          <a:xfrm>
-            <a:off x="1325880" y="3657600"/>
-            <a:ext cx="1691640" cy="292608"/>
-          </a:xfrm>
-          <a:prstGeom prst="rect">
-            <a:avLst/>
-          </a:prstGeom>
-          <a:solidFill>
-            <a:srgbClr val="3A3F4B"/>
-          </a:solidFill>
-          <a:ln w="15875">
-            <a:solidFill>
-              <a:srgbClr val="3A3F4B"/>
-            </a:solidFill>
-            <a:prstDash val="solid"/>
-          </a:ln>
-        </p:spPr>
-      </p:sp>
-      <p:sp>
-        <p:nvSpPr>
-          <p:cNvPr id="41" name="Text 39"/>
-          <p:cNvSpPr txBox="1"/>
-          <p:nvPr/>
-        </p:nvSpPr>
-        <p:spPr>
-          <a:xfrm>
-            <a:off x="1325880" y="3657600"/>
-            <a:ext cx="1691640" cy="292608"/>
-          </a:xfrm>
-          <a:prstGeom prst="rect">
-            <a:avLst/>
-          </a:prstGeom>
-          <a:noFill/>
-          <a:ln/>
-        </p:spPr>
-        <p:txBody>
-          <a:bodyPr wrap="square" lIns="0" tIns="0" rIns="0" bIns="0" rtlCol="0" anchor="ctr"/>
-          <a:lstStyle/>
-          <a:p>
-            <a:pPr algn="ctr" indent="0" marL="0">
-              <a:buNone/>
-            </a:pPr>
-            <a:r>
-              <a:rPr lang="en-US" sz="1100" b="1" dirty="0">
-                <a:solidFill>
-                  <a:srgbClr val="FFFFFF"/>
-                </a:solidFill>
-                <a:latin typeface="Calibri" pitchFamily="34" charset="0"/>
-                <a:ea typeface="Calibri" pitchFamily="34" charset="-122"/>
-                <a:cs typeface="Calibri" pitchFamily="34" charset="-120"/>
-              </a:rPr>
-              <a:t>SeguroViaje</a:t>
-            </a:r>
-            <a:endParaRPr lang="en-US" sz="1400" dirty="0"/>
-          </a:p>
-        </p:txBody>
-      </p:sp>
-      <p:sp>
-        <p:nvSpPr>
-          <p:cNvPr id="42" name="Text 40"/>
-          <p:cNvSpPr txBox="1"/>
-          <p:nvPr/>
-        </p:nvSpPr>
-        <p:spPr>
-          <a:xfrm>
-            <a:off x="1399032" y="3995928"/>
-            <a:ext cx="1581912" cy="219456"/>
-          </a:xfrm>
-          <a:prstGeom prst="rect">
-            <a:avLst/>
-          </a:prstGeom>
-          <a:noFill/>
-          <a:ln/>
-        </p:spPr>
-        <p:txBody>
-          <a:bodyPr wrap="square" lIns="0" tIns="0" rIns="0" bIns="0" rtlCol="0" anchor="t"/>
-          <a:lstStyle/>
-          <a:p>
-            <a:pPr indent="0" marL="0">
-              <a:buNone/>
-            </a:pPr>
-            <a:r>
-              <a:rPr lang="en-US" sz="850" dirty="0">
-                <a:solidFill>
-                  <a:srgbClr val="1B2333"/>
-                </a:solidFill>
-                <a:latin typeface="Courier New" pitchFamily="34" charset="0"/>
-                <a:ea typeface="Courier New" pitchFamily="34" charset="-122"/>
-                <a:cs typeface="Courier New" pitchFamily="34" charset="-120"/>
-              </a:rPr>
-              <a:t>+ costo()</a:t>
-            </a:r>
-            <a:endParaRPr lang="en-US" sz="850" dirty="0"/>
-          </a:p>
-        </p:txBody>
-      </p:sp>
-      <p:sp>
-        <p:nvSpPr>
-          <p:cNvPr id="43" name="Shape 41"/>
-          <p:cNvSpPr/>
-          <p:nvPr/>
-        </p:nvSpPr>
-        <p:spPr>
-          <a:xfrm>
-            <a:off x="3246120" y="3657600"/>
-            <a:ext cx="1691640" cy="557784"/>
-          </a:xfrm>
-          <a:prstGeom prst="rect">
-            <a:avLst/>
-          </a:prstGeom>
-          <a:solidFill>
-            <a:srgbClr val="FFFFFF"/>
-          </a:solidFill>
-          <a:ln w="15875">
-            <a:solidFill>
-              <a:srgbClr val="3A3F4B"/>
-            </a:solidFill>
-            <a:prstDash val="solid"/>
-          </a:ln>
-        </p:spPr>
-      </p:sp>
-      <p:sp>
-        <p:nvSpPr>
-          <p:cNvPr id="44" name="Shape 42"/>
-          <p:cNvSpPr/>
-          <p:nvPr/>
-        </p:nvSpPr>
-        <p:spPr>
-          <a:xfrm>
-            <a:off x="3246120" y="3657600"/>
-            <a:ext cx="1691640" cy="292608"/>
-          </a:xfrm>
-          <a:prstGeom prst="rect">
-            <a:avLst/>
-          </a:prstGeom>
-          <a:solidFill>
-            <a:srgbClr val="3A3F4B"/>
-          </a:solidFill>
-          <a:ln w="15875">
-            <a:solidFill>
-              <a:srgbClr val="3A3F4B"/>
-            </a:solidFill>
-            <a:prstDash val="solid"/>
-          </a:ln>
-        </p:spPr>
-      </p:sp>
-      <p:sp>
-        <p:nvSpPr>
-          <p:cNvPr id="45" name="Text 43"/>
-          <p:cNvSpPr txBox="1"/>
-          <p:nvPr/>
-        </p:nvSpPr>
-        <p:spPr>
-          <a:xfrm>
-            <a:off x="3246120" y="3657600"/>
-            <a:ext cx="1691640" cy="292608"/>
-          </a:xfrm>
-          <a:prstGeom prst="rect">
-            <a:avLst/>
-          </a:prstGeom>
-          <a:noFill/>
-          <a:ln/>
-        </p:spPr>
-        <p:txBody>
-          <a:bodyPr wrap="square" lIns="0" tIns="0" rIns="0" bIns="0" rtlCol="0" anchor="ctr"/>
-          <a:lstStyle/>
-          <a:p>
-            <a:pPr algn="ctr" indent="0" marL="0">
-              <a:buNone/>
-            </a:pPr>
-            <a:r>
-              <a:rPr lang="en-US" sz="1100" b="1" dirty="0">
-                <a:solidFill>
-                  <a:srgbClr val="FFFFFF"/>
-                </a:solidFill>
-                <a:latin typeface="Calibri" pitchFamily="34" charset="0"/>
-                <a:ea typeface="Calibri" pitchFamily="34" charset="-122"/>
-                <a:cs typeface="Calibri" pitchFamily="34" charset="-120"/>
-              </a:rPr>
-              <a:t>EquipajeExtra</a:t>
-            </a:r>
-            <a:endParaRPr lang="en-US" sz="1400" dirty="0"/>
-          </a:p>
-        </p:txBody>
-      </p:sp>
-      <p:sp>
-        <p:nvSpPr>
-          <p:cNvPr id="46" name="Text 44"/>
-          <p:cNvSpPr txBox="1"/>
-          <p:nvPr/>
-        </p:nvSpPr>
-        <p:spPr>
-          <a:xfrm>
-            <a:off x="3319272" y="3995928"/>
-            <a:ext cx="1581912" cy="219456"/>
-          </a:xfrm>
-          <a:prstGeom prst="rect">
-            <a:avLst/>
-          </a:prstGeom>
-          <a:noFill/>
-          <a:ln/>
-        </p:spPr>
-        <p:txBody>
-          <a:bodyPr wrap="square" lIns="0" tIns="0" rIns="0" bIns="0" rtlCol="0" anchor="t"/>
-          <a:lstStyle/>
-          <a:p>
-            <a:pPr indent="0" marL="0">
-              <a:buNone/>
-            </a:pPr>
-            <a:r>
-              <a:rPr lang="en-US" sz="850" dirty="0">
-                <a:solidFill>
-                  <a:srgbClr val="1B2333"/>
-                </a:solidFill>
-                <a:latin typeface="Courier New" pitchFamily="34" charset="0"/>
-                <a:ea typeface="Courier New" pitchFamily="34" charset="-122"/>
-                <a:cs typeface="Courier New" pitchFamily="34" charset="-120"/>
-              </a:rPr>
-              <a:t>- kilos: int</a:t>
-            </a:r>
-            <a:endParaRPr lang="en-US" sz="850" dirty="0"/>
-          </a:p>
-        </p:txBody>
-      </p:sp>
-      <p:sp>
-        <p:nvSpPr>
-          <p:cNvPr id="47" name="Shape 45"/>
-          <p:cNvSpPr/>
-          <p:nvPr/>
-        </p:nvSpPr>
-        <p:spPr>
-          <a:xfrm>
-            <a:off x="5166360" y="3657600"/>
-            <a:ext cx="1691640" cy="557784"/>
-          </a:xfrm>
-          <a:prstGeom prst="rect">
-            <a:avLst/>
-          </a:prstGeom>
-          <a:solidFill>
-            <a:srgbClr val="FFFFFF"/>
-          </a:solidFill>
-          <a:ln w="15875">
-            <a:solidFill>
-              <a:srgbClr val="3A3F4B"/>
-            </a:solidFill>
-            <a:prstDash val="solid"/>
-          </a:ln>
-        </p:spPr>
-      </p:sp>
-      <p:sp>
-        <p:nvSpPr>
-          <p:cNvPr id="48" name="Shape 46"/>
-          <p:cNvSpPr/>
-          <p:nvPr/>
-        </p:nvSpPr>
-        <p:spPr>
-          <a:xfrm>
-            <a:off x="5166360" y="3657600"/>
-            <a:ext cx="1691640" cy="292608"/>
-          </a:xfrm>
-          <a:prstGeom prst="rect">
-            <a:avLst/>
-          </a:prstGeom>
-          <a:solidFill>
-            <a:srgbClr val="3A3F4B"/>
-          </a:solidFill>
-          <a:ln w="15875">
-            <a:solidFill>
-              <a:srgbClr val="3A3F4B"/>
-            </a:solidFill>
-            <a:prstDash val="solid"/>
-          </a:ln>
-        </p:spPr>
-      </p:sp>
-      <p:sp>
-        <p:nvSpPr>
-          <p:cNvPr id="49" name="Text 47"/>
-          <p:cNvSpPr txBox="1"/>
-          <p:nvPr/>
-        </p:nvSpPr>
-        <p:spPr>
-          <a:xfrm>
-            <a:off x="5166360" y="3657600"/>
-            <a:ext cx="1691640" cy="292608"/>
-          </a:xfrm>
-          <a:prstGeom prst="rect">
-            <a:avLst/>
-          </a:prstGeom>
-          <a:noFill/>
-          <a:ln/>
-        </p:spPr>
-        <p:txBody>
-          <a:bodyPr wrap="square" lIns="0" tIns="0" rIns="0" bIns="0" rtlCol="0" anchor="ctr"/>
-          <a:lstStyle/>
-          <a:p>
-            <a:pPr algn="ctr" indent="0" marL="0">
-              <a:buNone/>
-            </a:pPr>
-            <a:r>
-              <a:rPr lang="en-US" sz="1100" b="1" dirty="0">
-                <a:solidFill>
-                  <a:srgbClr val="FFFFFF"/>
-                </a:solidFill>
-                <a:latin typeface="Calibri" pitchFamily="34" charset="0"/>
-                <a:ea typeface="Calibri" pitchFamily="34" charset="-122"/>
-                <a:cs typeface="Calibri" pitchFamily="34" charset="-120"/>
-              </a:rPr>
-              <a:t>RefrigerioABordo</a:t>
-            </a:r>
-            <a:endParaRPr lang="en-US" sz="1400" dirty="0"/>
-          </a:p>
-        </p:txBody>
-      </p:sp>
-      <p:sp>
-        <p:nvSpPr>
-          <p:cNvPr id="50" name="Text 48"/>
-          <p:cNvSpPr txBox="1"/>
-          <p:nvPr/>
-        </p:nvSpPr>
-        <p:spPr>
-          <a:xfrm>
-            <a:off x="5239512" y="3995928"/>
-            <a:ext cx="1581912" cy="219456"/>
-          </a:xfrm>
-          <a:prstGeom prst="rect">
-            <a:avLst/>
-          </a:prstGeom>
-          <a:noFill/>
-          <a:ln/>
-        </p:spPr>
-        <p:txBody>
-          <a:bodyPr wrap="square" lIns="0" tIns="0" rIns="0" bIns="0" rtlCol="0" anchor="t"/>
-          <a:lstStyle/>
-          <a:p>
-            <a:pPr indent="0" marL="0">
-              <a:buNone/>
-            </a:pPr>
-            <a:r>
-              <a:rPr lang="en-US" sz="850" dirty="0">
-                <a:solidFill>
-                  <a:srgbClr val="1B2333"/>
-                </a:solidFill>
-                <a:latin typeface="Courier New" pitchFamily="34" charset="0"/>
-                <a:ea typeface="Courier New" pitchFamily="34" charset="-122"/>
-                <a:cs typeface="Courier New" pitchFamily="34" charset="-120"/>
-              </a:rPr>
-              <a:t>+ costo()</a:t>
-            </a:r>
-            <a:endParaRPr lang="en-US" sz="850" dirty="0"/>
-          </a:p>
-        </p:txBody>
-      </p:sp>
-      <p:sp>
-        <p:nvSpPr>
-          <p:cNvPr id="51" name="Shape 49"/>
-          <p:cNvSpPr/>
-          <p:nvPr/>
-        </p:nvSpPr>
-        <p:spPr>
-          <a:xfrm>
-            <a:off x="2194560" y="1188720"/>
-            <a:ext cx="960120" cy="0"/>
-          </a:xfrm>
-          <a:prstGeom prst="line">
-            <a:avLst/>
-          </a:prstGeom>
-          <a:noFill/>
-          <a:ln w="15875">
-            <a:solidFill>
-              <a:srgbClr val="3A3F4B"/>
-            </a:solidFill>
-            <a:prstDash val="solid"/>
-            <a:tailEnd type="arrow"/>
-          </a:ln>
-        </p:spPr>
-      </p:sp>
-      <p:sp>
-        <p:nvSpPr>
-          <p:cNvPr id="52" name="Shape 50"/>
-          <p:cNvSpPr/>
-          <p:nvPr/>
-        </p:nvSpPr>
-        <p:spPr>
-          <a:xfrm flipV="1">
-            <a:off x="1645920" y="1856232"/>
-            <a:ext cx="1965960" cy="521208"/>
-          </a:xfrm>
-          <a:prstGeom prst="line">
-            <a:avLst/>
-          </a:prstGeom>
-          <a:noFill/>
-          <a:ln w="15875">
-            <a:solidFill>
-              <a:srgbClr val="3A3F4B"/>
-            </a:solidFill>
-            <a:prstDash val="dash"/>
-            <a:tailEnd type="triangle"/>
-          </a:ln>
-        </p:spPr>
-      </p:sp>
-      <p:sp>
-        <p:nvSpPr>
-          <p:cNvPr id="53" name="Shape 51"/>
-          <p:cNvSpPr/>
-          <p:nvPr/>
-        </p:nvSpPr>
-        <p:spPr>
-          <a:xfrm flipV="1">
-            <a:off x="4389120" y="1856232"/>
-            <a:ext cx="0" cy="521208"/>
-          </a:xfrm>
-          <a:prstGeom prst="line">
-            <a:avLst/>
-          </a:prstGeom>
-          <a:noFill/>
-          <a:ln w="15875">
-            <a:solidFill>
-              <a:srgbClr val="3A3F4B"/>
-            </a:solidFill>
-            <a:prstDash val="dash"/>
-            <a:tailEnd type="triangle"/>
-          </a:ln>
-        </p:spPr>
-      </p:sp>
-      <p:sp>
-        <p:nvSpPr>
-          <p:cNvPr id="54" name="Shape 52"/>
-          <p:cNvSpPr/>
-          <p:nvPr/>
-        </p:nvSpPr>
-        <p:spPr>
-          <a:xfrm flipV="1">
-            <a:off x="2171700" y="3282696"/>
-            <a:ext cx="2217420" cy="374904"/>
-          </a:xfrm>
-          <a:prstGeom prst="line">
-            <a:avLst/>
-          </a:prstGeom>
-          <a:noFill/>
-          <a:ln w="15875">
-            <a:solidFill>
-              <a:srgbClr val="3A3F4B"/>
-            </a:solidFill>
-            <a:prstDash val="solid"/>
-            <a:tailEnd type="triangle"/>
-          </a:ln>
-        </p:spPr>
-      </p:sp>
-      <p:sp>
-        <p:nvSpPr>
-          <p:cNvPr id="55" name="Shape 53"/>
-          <p:cNvSpPr/>
-          <p:nvPr/>
-        </p:nvSpPr>
-        <p:spPr>
-          <a:xfrm flipV="1">
-            <a:off x="4091940" y="3282696"/>
-            <a:ext cx="297180" cy="374904"/>
-          </a:xfrm>
-          <a:prstGeom prst="line">
-            <a:avLst/>
-          </a:prstGeom>
-          <a:noFill/>
-          <a:ln w="15875">
-            <a:solidFill>
-              <a:srgbClr val="3A3F4B"/>
-            </a:solidFill>
-            <a:prstDash val="solid"/>
-            <a:tailEnd type="triangle"/>
-          </a:ln>
-        </p:spPr>
-      </p:sp>
-      <p:sp>
-        <p:nvSpPr>
-          <p:cNvPr id="56" name="Shape 54"/>
-          <p:cNvSpPr/>
-          <p:nvPr/>
-        </p:nvSpPr>
-        <p:spPr>
-          <a:xfrm flipH="1" flipV="1">
-            <a:off x="4389120" y="3282696"/>
-            <a:ext cx="1623060" cy="374904"/>
-          </a:xfrm>
-          <a:prstGeom prst="line">
-            <a:avLst/>
-          </a:prstGeom>
-          <a:noFill/>
-          <a:ln w="15875">
-            <a:solidFill>
-              <a:srgbClr val="3A3F4B"/>
-            </a:solidFill>
-            <a:prstDash val="solid"/>
-            <a:tailEnd type="triangle"/>
-          </a:ln>
-        </p:spPr>
-      </p:sp>
-      <p:sp>
-        <p:nvSpPr>
-          <p:cNvPr id="57" name="Shape 55"/>
-          <p:cNvSpPr/>
-          <p:nvPr/>
-        </p:nvSpPr>
-        <p:spPr>
-          <a:xfrm>
-            <a:off x="5623560" y="2880360"/>
-            <a:ext cx="457200" cy="0"/>
-          </a:xfrm>
-          <a:prstGeom prst="line">
-            <a:avLst/>
-          </a:prstGeom>
-          <a:noFill/>
-          <a:ln w="15875">
-            <a:solidFill>
-              <a:srgbClr val="3A3F4B"/>
-            </a:solidFill>
-            <a:prstDash val="solid"/>
-            <a:tailEnd type="none"/>
-          </a:ln>
-        </p:spPr>
-      </p:sp>
-      <p:sp>
-        <p:nvSpPr>
-          <p:cNvPr id="58" name="Shape 56"/>
-          <p:cNvSpPr/>
-          <p:nvPr/>
-        </p:nvSpPr>
-        <p:spPr>
-          <a:xfrm flipV="1">
-            <a:off x="6080760" y="1600200"/>
-            <a:ext cx="0" cy="1280160"/>
-          </a:xfrm>
-          <a:prstGeom prst="line">
-            <a:avLst/>
-          </a:prstGeom>
-          <a:noFill/>
-          <a:ln w="15875">
-            <a:solidFill>
-              <a:srgbClr val="3A3F4B"/>
-            </a:solidFill>
-            <a:prstDash val="solid"/>
-            <a:tailEnd type="none"/>
-          </a:ln>
-        </p:spPr>
-      </p:sp>
-      <p:sp>
-        <p:nvSpPr>
-          <p:cNvPr id="59" name="Shape 57"/>
-          <p:cNvSpPr/>
-          <p:nvPr/>
-        </p:nvSpPr>
-        <p:spPr>
-          <a:xfrm flipH="1">
-            <a:off x="5623560" y="1600200"/>
-            <a:ext cx="457200" cy="0"/>
-          </a:xfrm>
-          <a:prstGeom prst="line">
-            <a:avLst/>
-          </a:prstGeom>
-          <a:noFill/>
-          <a:ln w="15875">
-            <a:solidFill>
-              <a:srgbClr val="3A3F4B"/>
-            </a:solidFill>
-            <a:prstDash val="solid"/>
-            <a:tailEnd type="arrow"/>
-          </a:ln>
-        </p:spPr>
-      </p:sp>
-      <p:sp>
-        <p:nvSpPr>
-          <p:cNvPr id="60" name="Text 58"/>
-          <p:cNvSpPr txBox="1"/>
-          <p:nvPr/>
-        </p:nvSpPr>
-        <p:spPr>
-          <a:xfrm>
-            <a:off x="6126480" y="1920240"/>
-            <a:ext cx="914400" cy="228600"/>
-          </a:xfrm>
-          <a:prstGeom prst="rect">
-            <a:avLst/>
-          </a:prstGeom>
-          <a:noFill/>
-          <a:ln/>
-        </p:spPr>
-        <p:txBody>
-          <a:bodyPr wrap="square" lIns="0" tIns="0" rIns="0" bIns="0" rtlCol="0" anchor="t"/>
-          <a:lstStyle/>
-          <a:p>
-            <a:pPr indent="0" marL="0">
-              <a:buNone/>
-            </a:pPr>
-            <a:r>
-              <a:rPr lang="en-US" sz="900" i="1" dirty="0">
-                <a:solidFill>
-                  <a:srgbClr val="5B6577"/>
-                </a:solidFill>
-                <a:latin typeface="Calibri" pitchFamily="34" charset="0"/>
-                <a:ea typeface="Calibri" pitchFamily="34" charset="-122"/>
-                <a:cs typeface="Calibri" pitchFamily="34" charset="-120"/>
-              </a:rPr>
-              <a:t>envuelve a</a:t>
-            </a:r>
-            <a:endParaRPr lang="en-US" sz="900" dirty="0"/>
-          </a:p>
-        </p:txBody>
-      </p:sp>
-      <p:sp>
-        <p:nvSpPr>
           <p:cNvPr id="61" name="Shape 59"/>
           <p:cNvSpPr/>
           <p:nvPr/>
@@ -46374,6 +42525,30 @@
           </a:p>
         </p:txBody>
       </p:sp>
+      <p:pic>
+        <p:nvPicPr>
+          <p:cNvPr id="75" name="Picture 74" descr="clases.png"/>
+          <p:cNvPicPr>
+            <a:picLocks noChangeAspect="1"/>
+          </p:cNvPicPr>
+          <p:nvPr/>
+        </p:nvPicPr>
+        <p:blipFill>
+          <a:blip r:embed="rId3"/>
+          <a:stretch>
+            <a:fillRect/>
+          </a:stretch>
+        </p:blipFill>
+        <p:spPr>
+          <a:xfrm>
+            <a:off x="1276309" y="960120"/>
+            <a:ext cx="4671142" cy="3593592"/>
+          </a:xfrm>
+          <a:prstGeom prst="rect">
+            <a:avLst/>
+          </a:prstGeom>
+        </p:spPr>
+      </p:pic>
     </p:spTree>
   </p:cSld>
   <p:clrMapOvr>

</xml_diff>